<commit_message>
docs: update project presentation slides for parking lot management system
</commit_message>
<xml_diff>
--- a/docs/Slides_DoAn_QuanLyChuoiBaiDoXe.pptx
+++ b/docs/Slides_DoAn_QuanLyChuoiBaiDoXe.pptx
@@ -9672,7 +9672,7 @@
               </a:defRPr>
             </a:pPr>
             <a:r>
-              <a:t>    Security Policy rls_KhachHang + Predicate Function fn_security_predicate_makh</a:t>
+              <a:t>    Security Policy bao_mat.rls_KhachHang + Predicate Function bao_mat.fn_rls_KhachHang / fn_rls_GiaoDich</a:t>
             </a:r>
           </a:p>
         </p:txBody>
@@ -10602,7 +10602,7 @@
               </a:defRPr>
             </a:pPr>
             <a:r>
-              <a:t>Đảm bảo tính minh bạch kế toán. Mọi giao dịch ghi nhận dạng Append-Only; Trigger chặn vĩnh viễn mọi hành vi sửa tiền (50061), xóa sổ cái (50060) hoặc hoàn tiền khoản đã xuất hóa đơn (50063).</a:t>
+              <a:t>Đảm bảo tính minh bạch kế toán. Mọi giao dịch ghi nhận dạng Append-Only; Trigger chặn vĩnh viễn mọi hành vi sửa tiền (50061), xóa sổ cái (50060), sửa trực tiếp số dư ví (50062); thủ tục hoàn tiền từ chối khoản đã xuất hóa đơn (50063).</a:t>
             </a:r>
           </a:p>
         </p:txBody>
@@ -10737,7 +10737,7 @@
               </a:defRPr>
             </a:pPr>
             <a:r>
-              <a:t>    - NK_LEDGER_TAI_CHINH (Sổ cái bất biến)</a:t>
+              <a:t>    - HOA_DON_VE_THANG (Kiểm tra khoản đã xuất hóa đơn trước khi hoàn tiền)</a:t>
             </a:r>
           </a:p>
           <a:p>
@@ -10785,7 +10785,7 @@
               </a:defRPr>
             </a:pPr>
             <a:r>
-              <a:t>    Trigger trg_GiaoDich_BatBien + Stored Procedure sp_NV_HoanTien (Ghi bút toán đối ứng)</a:t>
+              <a:t>    Trigger trg_GiaoDich_BatBien + trg_GiaoDich_ChanXoa + Stored Procedure sp_NV_HoanTien (Ghi bút toán đối ứng)</a:t>
             </a:r>
           </a:p>
         </p:txBody>
@@ -14372,7 +14372,7 @@
               </a:defRPr>
             </a:pPr>
             <a:r>
-              <a:t>    Stored Procedure sp_CapLaiThe + Filtered Unique Index UX_VeThang_MaThe_ConDung</a:t>
+              <a:t>    Stored Procedure sp_DangKyThanhVien + Function f_VeHienHanhCuaThe + Filtered Unique Index UX_VeThang_MaThe_ConDung</a:t>
             </a:r>
           </a:p>
         </p:txBody>

</xml_diff>

<commit_message>
chore: comment out customer portal demo group and update presentation slides
</commit_message>
<xml_diff>
--- a/docs/Slides_DoAn_QuanLyChuoiBaiDoXe.pptx
+++ b/docs/Slides_DoAn_QuanLyChuoiBaiDoXe.pptx
@@ -20,15 +20,6 @@
     <p:sldId id="268" r:id="rId14"/>
     <p:sldId id="269" r:id="rId15"/>
     <p:sldId id="270" r:id="rId16"/>
-    <p:sldId id="271" r:id="rId17"/>
-    <p:sldId id="272" r:id="rId18"/>
-    <p:sldId id="273" r:id="rId19"/>
-    <p:sldId id="274" r:id="rId20"/>
-    <p:sldId id="275" r:id="rId21"/>
-    <p:sldId id="276" r:id="rId22"/>
-    <p:sldId id="277" r:id="rId23"/>
-    <p:sldId id="278" r:id="rId24"/>
-    <p:sldId id="279" r:id="rId25"/>
   </p:sldIdLst>
   <p:sldSz cx="12192000" cy="6858000"/>
   <p:notesSz cx="6858000" cy="9144000"/>
@@ -5731,1599 +5722,6 @@
 </p:sld>
 </file>
 
-<file path=ppt/slides/slide16.xml><?xml version="1.0" encoding="utf-8"?>
-<p:sld xmlns:a="http://schemas.openxmlformats.org/drawingml/2006/main" xmlns:r="http://schemas.openxmlformats.org/officeDocument/2006/relationships" xmlns:p="http://schemas.openxmlformats.org/presentationml/2006/main">
-  <p:cSld>
-    <p:bg>
-      <p:bgPr>
-        <a:solidFill>
-          <a:srgbClr val="F8FAFC"/>
-        </a:solidFill>
-        <a:effectLst/>
-      </p:bgPr>
-    </p:bg>
-    <p:spTree>
-      <p:nvGrpSpPr>
-        <p:cNvPr id="1" name=""/>
-        <p:cNvGrpSpPr/>
-        <p:nvPr/>
-      </p:nvGrpSpPr>
-      <p:grpSpPr>
-        <a:xfrm>
-          <a:off x="0" y="0"/>
-          <a:ext cx="0" cy="0"/>
-          <a:chOff x="0" y="0"/>
-          <a:chExt cx="0" cy="0"/>
-        </a:xfrm>
-      </p:grpSpPr>
-      <p:sp>
-        <p:nvSpPr>
-          <p:cNvPr id="2" name="TextBox 1"/>
-          <p:cNvSpPr txBox="1"/>
-          <p:nvPr/>
-        </p:nvSpPr>
-        <p:spPr>
-          <a:xfrm>
-            <a:off x="731520" y="365760"/>
-            <a:ext cx="10728655" cy="533479"/>
-          </a:xfrm>
-          <a:prstGeom prst="rect">
-            <a:avLst/>
-          </a:prstGeom>
-          <a:noFill/>
-        </p:spPr>
-        <p:txBody>
-          <a:bodyPr wrap="square" lIns="0" tIns="0" rIns="0" bIns="0">
-            <a:spAutoFit/>
-          </a:bodyPr>
-          <a:lstStyle/>
-          <a:p>
-            <a:pPr>
-              <a:spcAft>
-                <a:spcPts val="200"/>
-              </a:spcAft>
-              <a:defRPr sz="1300" b="1">
-                <a:solidFill>
-                  <a:srgbClr val="0284C7"/>
-                </a:solidFill>
-                <a:latin typeface="Arial"/>
-              </a:defRPr>
-            </a:pPr>
-            <a:r>
-              <a:rPr dirty="0"/>
-              <a:t>KỊCH BẢN DEMO #13 — KH-DANG-KY-TAI-KHOAN</a:t>
-            </a:r>
-          </a:p>
-          <a:p>
-            <a:pPr>
-              <a:defRPr sz="2000" b="1">
-                <a:solidFill>
-                  <a:srgbClr val="0F172A"/>
-                </a:solidFill>
-                <a:latin typeface="Arial"/>
-              </a:defRPr>
-            </a:pPr>
-            <a:r>
-              <a:rPr dirty="0"/>
-              <a:t>DEMO 13: </a:t>
-            </a:r>
-            <a:r>
-              <a:rPr dirty="0" err="1"/>
-              <a:t>Khách</a:t>
-            </a:r>
-            <a:r>
-              <a:rPr dirty="0"/>
-              <a:t> Hàng </a:t>
-            </a:r>
-            <a:r>
-              <a:rPr dirty="0" err="1"/>
-              <a:t>Tự</a:t>
-            </a:r>
-            <a:r>
-              <a:rPr dirty="0"/>
-              <a:t> Đăng </a:t>
-            </a:r>
-            <a:r>
-              <a:rPr dirty="0" err="1"/>
-              <a:t>Ký</a:t>
-            </a:r>
-            <a:r>
-              <a:rPr dirty="0"/>
-              <a:t> Tài </a:t>
-            </a:r>
-            <a:r>
-              <a:rPr dirty="0" err="1"/>
-              <a:t>Khoản</a:t>
-            </a:r>
-            <a:endParaRPr dirty="0"/>
-          </a:p>
-        </p:txBody>
-      </p:sp>
-      <p:sp>
-        <p:nvSpPr>
-          <p:cNvPr id="3" name="Rounded Rectangle 2"/>
-          <p:cNvSpPr/>
-          <p:nvPr/>
-        </p:nvSpPr>
-        <p:spPr>
-          <a:xfrm>
-            <a:off x="731520" y="1280160"/>
-            <a:ext cx="5180990" cy="4937760"/>
-          </a:xfrm>
-          <a:prstGeom prst="roundRect">
-            <a:avLst>
-              <a:gd name="adj" fmla="val 1500"/>
-            </a:avLst>
-          </a:prstGeom>
-          <a:solidFill>
-            <a:srgbClr val="FFFFFF"/>
-          </a:solidFill>
-          <a:ln w="12700">
-            <a:solidFill>
-              <a:srgbClr val="E2E8F0"/>
-            </a:solidFill>
-          </a:ln>
-        </p:spPr>
-        <p:style>
-          <a:lnRef idx="1">
-            <a:schemeClr val="accent1"/>
-          </a:lnRef>
-          <a:fillRef idx="3">
-            <a:schemeClr val="accent1"/>
-          </a:fillRef>
-          <a:effectRef idx="2">
-            <a:schemeClr val="accent1"/>
-          </a:effectRef>
-          <a:fontRef idx="minor">
-            <a:schemeClr val="lt1"/>
-          </a:fontRef>
-        </p:style>
-        <p:txBody>
-          <a:bodyPr rtlCol="0" anchor="ctr"/>
-          <a:lstStyle/>
-          <a:p>
-            <a:pPr algn="ctr"/>
-            <a:endParaRPr/>
-          </a:p>
-        </p:txBody>
-      </p:sp>
-      <p:sp>
-        <p:nvSpPr>
-          <p:cNvPr id="4" name="TextBox 3"/>
-          <p:cNvSpPr txBox="1"/>
-          <p:nvPr/>
-        </p:nvSpPr>
-        <p:spPr>
-          <a:xfrm>
-            <a:off x="960120" y="1508760"/>
-            <a:ext cx="4723790" cy="4480560"/>
-          </a:xfrm>
-          <a:prstGeom prst="rect">
-            <a:avLst/>
-          </a:prstGeom>
-          <a:noFill/>
-        </p:spPr>
-        <p:txBody>
-          <a:bodyPr wrap="square" lIns="0" tIns="0" rIns="0" bIns="0">
-            <a:spAutoFit/>
-          </a:bodyPr>
-          <a:lstStyle/>
-          <a:p>
-            <a:pPr>
-              <a:spcAft>
-                <a:spcPts val="1000"/>
-              </a:spcAft>
-              <a:defRPr sz="1500" b="1">
-                <a:solidFill>
-                  <a:srgbClr val="0284C7"/>
-                </a:solidFill>
-                <a:latin typeface="Arial"/>
-              </a:defRPr>
-            </a:pPr>
-            <a:r>
-              <a:t>🎯 BÀI TOÁN NGHIỆP VỤ</a:t>
-            </a:r>
-          </a:p>
-          <a:p>
-            <a:pPr>
-              <a:lnSpc>
-                <a:spcPct val="125000"/>
-              </a:lnSpc>
-              <a:defRPr sz="1250">
-                <a:solidFill>
-                  <a:srgbClr val="0F172A"/>
-                </a:solidFill>
-                <a:latin typeface="Arial"/>
-              </a:defRPr>
-            </a:pPr>
-            <a:r>
-              <a:t>Khách hàng tự đăng ký tài khoản online qua SĐT &amp; CCCD trên Cổng khách hàng. Hệ thống khởi tạo tài khoản băm mật khẩu SHA2_512 và mở Ví điện tử 0đ trong 1 Transaction.</a:t>
-            </a:r>
-          </a:p>
-        </p:txBody>
-      </p:sp>
-      <p:sp>
-        <p:nvSpPr>
-          <p:cNvPr id="5" name="Rounded Rectangle 4"/>
-          <p:cNvSpPr/>
-          <p:nvPr/>
-        </p:nvSpPr>
-        <p:spPr>
-          <a:xfrm>
-            <a:off x="6278270" y="1280160"/>
-            <a:ext cx="5180990" cy="4937760"/>
-          </a:xfrm>
-          <a:prstGeom prst="roundRect">
-            <a:avLst>
-              <a:gd name="adj" fmla="val 1500"/>
-            </a:avLst>
-          </a:prstGeom>
-          <a:solidFill>
-            <a:srgbClr val="FFFFFF"/>
-          </a:solidFill>
-          <a:ln w="12700">
-            <a:solidFill>
-              <a:srgbClr val="E2E8F0"/>
-            </a:solidFill>
-          </a:ln>
-        </p:spPr>
-        <p:style>
-          <a:lnRef idx="1">
-            <a:schemeClr val="accent1"/>
-          </a:lnRef>
-          <a:fillRef idx="3">
-            <a:schemeClr val="accent1"/>
-          </a:fillRef>
-          <a:effectRef idx="2">
-            <a:schemeClr val="accent1"/>
-          </a:effectRef>
-          <a:fontRef idx="minor">
-            <a:schemeClr val="lt1"/>
-          </a:fontRef>
-        </p:style>
-        <p:txBody>
-          <a:bodyPr rtlCol="0" anchor="ctr"/>
-          <a:lstStyle/>
-          <a:p>
-            <a:pPr algn="ctr"/>
-            <a:endParaRPr/>
-          </a:p>
-        </p:txBody>
-      </p:sp>
-      <p:sp>
-        <p:nvSpPr>
-          <p:cNvPr id="6" name="TextBox 5"/>
-          <p:cNvSpPr txBox="1"/>
-          <p:nvPr/>
-        </p:nvSpPr>
-        <p:spPr>
-          <a:xfrm>
-            <a:off x="6506870" y="1508760"/>
-            <a:ext cx="4723790" cy="4480560"/>
-          </a:xfrm>
-          <a:prstGeom prst="rect">
-            <a:avLst/>
-          </a:prstGeom>
-          <a:noFill/>
-        </p:spPr>
-        <p:txBody>
-          <a:bodyPr wrap="square" lIns="0" tIns="0" rIns="0" bIns="0">
-            <a:spAutoFit/>
-          </a:bodyPr>
-          <a:lstStyle/>
-          <a:p>
-            <a:pPr>
-              <a:spcAft>
-                <a:spcPts val="1000"/>
-              </a:spcAft>
-              <a:defRPr sz="1400" b="1">
-                <a:solidFill>
-                  <a:srgbClr val="0F172A"/>
-                </a:solidFill>
-                <a:latin typeface="Arial"/>
-              </a:defRPr>
-            </a:pPr>
-            <a:r>
-              <a:t>🗄️ CÁC BẢNG DỮ LIỆU &amp; ĐỐI TƯỢNG CSDL LIÊN QUAN</a:t>
-            </a:r>
-          </a:p>
-          <a:p>
-            <a:pPr>
-              <a:spcAft>
-                <a:spcPts val="400"/>
-              </a:spcAft>
-              <a:defRPr sz="1200" b="1">
-                <a:solidFill>
-                  <a:srgbClr val="0F172A"/>
-                </a:solidFill>
-                <a:latin typeface="Arial"/>
-              </a:defRPr>
-            </a:pPr>
-            <a:r>
-              <a:t>• Các bảng dữ liệu bị ảnh hưởng / truy vấn:</a:t>
-            </a:r>
-          </a:p>
-          <a:p>
-            <a:pPr>
-              <a:spcAft>
-                <a:spcPts val="300"/>
-              </a:spcAft>
-              <a:defRPr sz="1150">
-                <a:solidFill>
-                  <a:srgbClr val="0F172A"/>
-                </a:solidFill>
-                <a:latin typeface="Arial"/>
-              </a:defRPr>
-            </a:pPr>
-            <a:r>
-              <a:t>    - TAI_KHOAN_KH (Tạo tài khoản khách hàng mới)</a:t>
-            </a:r>
-          </a:p>
-          <a:p>
-            <a:pPr>
-              <a:spcAft>
-                <a:spcPts val="300"/>
-              </a:spcAft>
-              <a:defRPr sz="1150">
-                <a:solidFill>
-                  <a:srgbClr val="0F172A"/>
-                </a:solidFill>
-                <a:latin typeface="Arial"/>
-              </a:defRPr>
-            </a:pPr>
-            <a:r>
-              <a:t>    - VI_DIEN_TU (Khởi tạo Ví điện tử trả trước 0đ)</a:t>
-            </a:r>
-          </a:p>
-          <a:p>
-            <a:pPr>
-              <a:spcAft>
-                <a:spcPts val="300"/>
-              </a:spcAft>
-              <a:defRPr sz="1150">
-                <a:solidFill>
-                  <a:srgbClr val="0F172A"/>
-                </a:solidFill>
-                <a:latin typeface="Arial"/>
-              </a:defRPr>
-            </a:pPr>
-            <a:r>
-              <a:t>    - KHACH_HANG (Xác minh thông tin chủ thể)</a:t>
-            </a:r>
-          </a:p>
-          <a:p>
-            <a:pPr>
-              <a:spcBef>
-                <a:spcPts val="800"/>
-              </a:spcBef>
-              <a:spcAft>
-                <a:spcPts val="400"/>
-              </a:spcAft>
-              <a:defRPr sz="1200" b="1">
-                <a:solidFill>
-                  <a:srgbClr val="0284C7"/>
-                </a:solidFill>
-                <a:latin typeface="Arial"/>
-              </a:defRPr>
-            </a:pPr>
-            <a:r>
-              <a:t>• Đối tượng T-SQL xử lý cốt lõi:</a:t>
-            </a:r>
-          </a:p>
-          <a:p>
-            <a:pPr>
-              <a:defRPr sz="1150" b="1">
-                <a:solidFill>
-                  <a:srgbClr val="0F172A"/>
-                </a:solidFill>
-                <a:latin typeface="Arial"/>
-              </a:defRPr>
-            </a:pPr>
-            <a:r>
-              <a:t>    Stored Procedure sp_KH_DangKyTaiKhoan</a:t>
-            </a:r>
-          </a:p>
-        </p:txBody>
-      </p:sp>
-    </p:spTree>
-  </p:cSld>
-  <p:clrMapOvr>
-    <a:masterClrMapping/>
-  </p:clrMapOvr>
-</p:sld>
-</file>
-
-<file path=ppt/slides/slide17.xml><?xml version="1.0" encoding="utf-8"?>
-<p:sld xmlns:a="http://schemas.openxmlformats.org/drawingml/2006/main" xmlns:r="http://schemas.openxmlformats.org/officeDocument/2006/relationships" xmlns:p="http://schemas.openxmlformats.org/presentationml/2006/main">
-  <p:cSld>
-    <p:bg>
-      <p:bgPr>
-        <a:solidFill>
-          <a:srgbClr val="F8FAFC"/>
-        </a:solidFill>
-        <a:effectLst/>
-      </p:bgPr>
-    </p:bg>
-    <p:spTree>
-      <p:nvGrpSpPr>
-        <p:cNvPr id="1" name=""/>
-        <p:cNvGrpSpPr/>
-        <p:nvPr/>
-      </p:nvGrpSpPr>
-      <p:grpSpPr>
-        <a:xfrm>
-          <a:off x="0" y="0"/>
-          <a:ext cx="0" cy="0"/>
-          <a:chOff x="0" y="0"/>
-          <a:chExt cx="0" cy="0"/>
-        </a:xfrm>
-      </p:grpSpPr>
-      <p:sp>
-        <p:nvSpPr>
-          <p:cNvPr id="2" name="TextBox 1"/>
-          <p:cNvSpPr txBox="1"/>
-          <p:nvPr/>
-        </p:nvSpPr>
-        <p:spPr>
-          <a:xfrm>
-            <a:off x="731520" y="365760"/>
-            <a:ext cx="10728655" cy="533479"/>
-          </a:xfrm>
-          <a:prstGeom prst="rect">
-            <a:avLst/>
-          </a:prstGeom>
-          <a:noFill/>
-        </p:spPr>
-        <p:txBody>
-          <a:bodyPr wrap="square" lIns="0" tIns="0" rIns="0" bIns="0">
-            <a:spAutoFit/>
-          </a:bodyPr>
-          <a:lstStyle/>
-          <a:p>
-            <a:pPr>
-              <a:spcAft>
-                <a:spcPts val="200"/>
-              </a:spcAft>
-              <a:defRPr sz="1300" b="1">
-                <a:solidFill>
-                  <a:srgbClr val="0284C7"/>
-                </a:solidFill>
-                <a:latin typeface="Arial"/>
-              </a:defRPr>
-            </a:pPr>
-            <a:r>
-              <a:rPr dirty="0"/>
-              <a:t>KỊCH BẢN DEMO #14 — KH-DANG-NHAP-KHOA-TAI-KHOAN</a:t>
-            </a:r>
-          </a:p>
-          <a:p>
-            <a:pPr>
-              <a:defRPr sz="2000" b="1">
-                <a:solidFill>
-                  <a:srgbClr val="0F172A"/>
-                </a:solidFill>
-                <a:latin typeface="Arial"/>
-              </a:defRPr>
-            </a:pPr>
-            <a:r>
-              <a:rPr dirty="0"/>
-              <a:t>DEMO 14: </a:t>
-            </a:r>
-            <a:r>
-              <a:rPr dirty="0" err="1"/>
-              <a:t>Khóa</a:t>
-            </a:r>
-            <a:r>
-              <a:rPr dirty="0"/>
-              <a:t> Tài Khoản Khách </a:t>
-            </a:r>
-            <a:r>
-              <a:rPr lang="en-US" dirty="0"/>
-              <a:t>Khi </a:t>
-            </a:r>
-            <a:r>
-              <a:rPr lang="en-US" dirty="0" err="1"/>
-              <a:t>Nhập</a:t>
-            </a:r>
-            <a:r>
-              <a:rPr lang="en-US" dirty="0"/>
-              <a:t> Sai 5 </a:t>
-            </a:r>
-            <a:r>
-              <a:rPr lang="en-US" dirty="0" err="1"/>
-              <a:t>Lần</a:t>
-            </a:r>
-            <a:endParaRPr dirty="0"/>
-          </a:p>
-        </p:txBody>
-      </p:sp>
-      <p:sp>
-        <p:nvSpPr>
-          <p:cNvPr id="3" name="Rounded Rectangle 2"/>
-          <p:cNvSpPr/>
-          <p:nvPr/>
-        </p:nvSpPr>
-        <p:spPr>
-          <a:xfrm>
-            <a:off x="731520" y="1280160"/>
-            <a:ext cx="5180990" cy="4937760"/>
-          </a:xfrm>
-          <a:prstGeom prst="roundRect">
-            <a:avLst>
-              <a:gd name="adj" fmla="val 1500"/>
-            </a:avLst>
-          </a:prstGeom>
-          <a:solidFill>
-            <a:srgbClr val="FFFFFF"/>
-          </a:solidFill>
-          <a:ln w="12700">
-            <a:solidFill>
-              <a:srgbClr val="E2E8F0"/>
-            </a:solidFill>
-          </a:ln>
-        </p:spPr>
-        <p:style>
-          <a:lnRef idx="1">
-            <a:schemeClr val="accent1"/>
-          </a:lnRef>
-          <a:fillRef idx="3">
-            <a:schemeClr val="accent1"/>
-          </a:fillRef>
-          <a:effectRef idx="2">
-            <a:schemeClr val="accent1"/>
-          </a:effectRef>
-          <a:fontRef idx="minor">
-            <a:schemeClr val="lt1"/>
-          </a:fontRef>
-        </p:style>
-        <p:txBody>
-          <a:bodyPr rtlCol="0" anchor="ctr"/>
-          <a:lstStyle/>
-          <a:p>
-            <a:pPr algn="ctr"/>
-            <a:endParaRPr/>
-          </a:p>
-        </p:txBody>
-      </p:sp>
-      <p:sp>
-        <p:nvSpPr>
-          <p:cNvPr id="4" name="TextBox 3"/>
-          <p:cNvSpPr txBox="1"/>
-          <p:nvPr/>
-        </p:nvSpPr>
-        <p:spPr>
-          <a:xfrm>
-            <a:off x="960120" y="1508760"/>
-            <a:ext cx="4723790" cy="4480560"/>
-          </a:xfrm>
-          <a:prstGeom prst="rect">
-            <a:avLst/>
-          </a:prstGeom>
-          <a:noFill/>
-        </p:spPr>
-        <p:txBody>
-          <a:bodyPr wrap="square" lIns="0" tIns="0" rIns="0" bIns="0">
-            <a:spAutoFit/>
-          </a:bodyPr>
-          <a:lstStyle/>
-          <a:p>
-            <a:pPr>
-              <a:spcAft>
-                <a:spcPts val="1000"/>
-              </a:spcAft>
-              <a:defRPr sz="1500" b="1">
-                <a:solidFill>
-                  <a:srgbClr val="0284C7"/>
-                </a:solidFill>
-                <a:latin typeface="Arial"/>
-              </a:defRPr>
-            </a:pPr>
-            <a:r>
-              <a:t>🎯 BÀI TOÁN NGHIỆP VỤ</a:t>
-            </a:r>
-          </a:p>
-          <a:p>
-            <a:pPr>
-              <a:lnSpc>
-                <a:spcPct val="125000"/>
-              </a:lnSpc>
-              <a:defRPr sz="1250">
-                <a:solidFill>
-                  <a:srgbClr val="0F172A"/>
-                </a:solidFill>
-                <a:latin typeface="Arial"/>
-              </a:defRPr>
-            </a:pPr>
-            <a:r>
-              <a:t>Bảo vệ tài khoản khách hàng trước tấn công Brute-force. Nếu nhập sai mật khẩu 5 lần liên tiếp trong 15 phút, tài khoản sẽ tự động bị khóa tạm thời 15 phút.</a:t>
-            </a:r>
-          </a:p>
-        </p:txBody>
-      </p:sp>
-      <p:sp>
-        <p:nvSpPr>
-          <p:cNvPr id="5" name="Rounded Rectangle 4"/>
-          <p:cNvSpPr/>
-          <p:nvPr/>
-        </p:nvSpPr>
-        <p:spPr>
-          <a:xfrm>
-            <a:off x="6278270" y="1280160"/>
-            <a:ext cx="5180990" cy="4937760"/>
-          </a:xfrm>
-          <a:prstGeom prst="roundRect">
-            <a:avLst>
-              <a:gd name="adj" fmla="val 1500"/>
-            </a:avLst>
-          </a:prstGeom>
-          <a:solidFill>
-            <a:srgbClr val="FFFFFF"/>
-          </a:solidFill>
-          <a:ln w="12700">
-            <a:solidFill>
-              <a:srgbClr val="E2E8F0"/>
-            </a:solidFill>
-          </a:ln>
-        </p:spPr>
-        <p:style>
-          <a:lnRef idx="1">
-            <a:schemeClr val="accent1"/>
-          </a:lnRef>
-          <a:fillRef idx="3">
-            <a:schemeClr val="accent1"/>
-          </a:fillRef>
-          <a:effectRef idx="2">
-            <a:schemeClr val="accent1"/>
-          </a:effectRef>
-          <a:fontRef idx="minor">
-            <a:schemeClr val="lt1"/>
-          </a:fontRef>
-        </p:style>
-        <p:txBody>
-          <a:bodyPr rtlCol="0" anchor="ctr"/>
-          <a:lstStyle/>
-          <a:p>
-            <a:pPr algn="ctr"/>
-            <a:endParaRPr/>
-          </a:p>
-        </p:txBody>
-      </p:sp>
-      <p:sp>
-        <p:nvSpPr>
-          <p:cNvPr id="6" name="TextBox 5"/>
-          <p:cNvSpPr txBox="1"/>
-          <p:nvPr/>
-        </p:nvSpPr>
-        <p:spPr>
-          <a:xfrm>
-            <a:off x="6506870" y="1508760"/>
-            <a:ext cx="4723790" cy="4480560"/>
-          </a:xfrm>
-          <a:prstGeom prst="rect">
-            <a:avLst/>
-          </a:prstGeom>
-          <a:noFill/>
-        </p:spPr>
-        <p:txBody>
-          <a:bodyPr wrap="square" lIns="0" tIns="0" rIns="0" bIns="0">
-            <a:spAutoFit/>
-          </a:bodyPr>
-          <a:lstStyle/>
-          <a:p>
-            <a:pPr>
-              <a:spcAft>
-                <a:spcPts val="1000"/>
-              </a:spcAft>
-              <a:defRPr sz="1400" b="1">
-                <a:solidFill>
-                  <a:srgbClr val="0F172A"/>
-                </a:solidFill>
-                <a:latin typeface="Arial"/>
-              </a:defRPr>
-            </a:pPr>
-            <a:r>
-              <a:t>🗄️ CÁC BẢNG DỮ LIỆU &amp; ĐỐI TƯỢNG CSDL LIÊN QUAN</a:t>
-            </a:r>
-          </a:p>
-          <a:p>
-            <a:pPr>
-              <a:spcAft>
-                <a:spcPts val="400"/>
-              </a:spcAft>
-              <a:defRPr sz="1200" b="1">
-                <a:solidFill>
-                  <a:srgbClr val="0F172A"/>
-                </a:solidFill>
-                <a:latin typeface="Arial"/>
-              </a:defRPr>
-            </a:pPr>
-            <a:r>
-              <a:t>• Các bảng dữ liệu bị ảnh hưởng / truy vấn:</a:t>
-            </a:r>
-          </a:p>
-          <a:p>
-            <a:pPr>
-              <a:spcAft>
-                <a:spcPts val="300"/>
-              </a:spcAft>
-              <a:defRPr sz="1150">
-                <a:solidFill>
-                  <a:srgbClr val="0F172A"/>
-                </a:solidFill>
-                <a:latin typeface="Arial"/>
-              </a:defRPr>
-            </a:pPr>
-            <a:r>
-              <a:t>    - TAI_KHOAN_KH (Cập nhật trạng thái 'Khóa tạm thời')</a:t>
-            </a:r>
-          </a:p>
-          <a:p>
-            <a:pPr>
-              <a:spcAft>
-                <a:spcPts val="300"/>
-              </a:spcAft>
-              <a:defRPr sz="1150">
-                <a:solidFill>
-                  <a:srgbClr val="0F172A"/>
-                </a:solidFill>
-                <a:latin typeface="Arial"/>
-              </a:defRPr>
-            </a:pPr>
-            <a:r>
-              <a:t>    - NHAT_KY_DANG_NHAP (Lưu vết số lần đăng nhập thất bại)</a:t>
-            </a:r>
-          </a:p>
-          <a:p>
-            <a:pPr>
-              <a:spcBef>
-                <a:spcPts val="800"/>
-              </a:spcBef>
-              <a:spcAft>
-                <a:spcPts val="400"/>
-              </a:spcAft>
-              <a:defRPr sz="1200" b="1">
-                <a:solidFill>
-                  <a:srgbClr val="0284C7"/>
-                </a:solidFill>
-                <a:latin typeface="Arial"/>
-              </a:defRPr>
-            </a:pPr>
-            <a:r>
-              <a:t>• Đối tượng T-SQL xử lý cốt lõi:</a:t>
-            </a:r>
-          </a:p>
-          <a:p>
-            <a:pPr>
-              <a:defRPr sz="1150" b="1">
-                <a:solidFill>
-                  <a:srgbClr val="0F172A"/>
-                </a:solidFill>
-                <a:latin typeface="Arial"/>
-              </a:defRPr>
-            </a:pPr>
-            <a:r>
-              <a:t>    Stored Procedure sp_KH_DangNhap (Th Throw Error 50041)</a:t>
-            </a:r>
-          </a:p>
-        </p:txBody>
-      </p:sp>
-    </p:spTree>
-  </p:cSld>
-  <p:clrMapOvr>
-    <a:masterClrMapping/>
-  </p:clrMapOvr>
-</p:sld>
-</file>
-
-<file path=ppt/slides/slide18.xml><?xml version="1.0" encoding="utf-8"?>
-<p:sld xmlns:a="http://schemas.openxmlformats.org/drawingml/2006/main" xmlns:r="http://schemas.openxmlformats.org/officeDocument/2006/relationships" xmlns:p="http://schemas.openxmlformats.org/presentationml/2006/main">
-  <p:cSld>
-    <p:bg>
-      <p:bgPr>
-        <a:solidFill>
-          <a:srgbClr val="F8FAFC"/>
-        </a:solidFill>
-        <a:effectLst/>
-      </p:bgPr>
-    </p:bg>
-    <p:spTree>
-      <p:nvGrpSpPr>
-        <p:cNvPr id="1" name=""/>
-        <p:cNvGrpSpPr/>
-        <p:nvPr/>
-      </p:nvGrpSpPr>
-      <p:grpSpPr>
-        <a:xfrm>
-          <a:off x="0" y="0"/>
-          <a:ext cx="0" cy="0"/>
-          <a:chOff x="0" y="0"/>
-          <a:chExt cx="0" cy="0"/>
-        </a:xfrm>
-      </p:grpSpPr>
-      <p:sp>
-        <p:nvSpPr>
-          <p:cNvPr id="2" name="TextBox 1"/>
-          <p:cNvSpPr txBox="1"/>
-          <p:nvPr/>
-        </p:nvSpPr>
-        <p:spPr>
-          <a:xfrm>
-            <a:off x="731520" y="365760"/>
-            <a:ext cx="10728655" cy="533479"/>
-          </a:xfrm>
-          <a:prstGeom prst="rect">
-            <a:avLst/>
-          </a:prstGeom>
-          <a:noFill/>
-        </p:spPr>
-        <p:txBody>
-          <a:bodyPr wrap="square" lIns="0" tIns="0" rIns="0" bIns="0">
-            <a:spAutoFit/>
-          </a:bodyPr>
-          <a:lstStyle/>
-          <a:p>
-            <a:pPr>
-              <a:spcAft>
-                <a:spcPts val="200"/>
-              </a:spcAft>
-              <a:defRPr sz="1300" b="1">
-                <a:solidFill>
-                  <a:srgbClr val="0284C7"/>
-                </a:solidFill>
-                <a:latin typeface="Arial"/>
-              </a:defRPr>
-            </a:pPr>
-            <a:r>
-              <a:rPr dirty="0"/>
-              <a:t>KỊCH BẢN DEMO #15 — KH-NAP-TIEN-2-PHA</a:t>
-            </a:r>
-          </a:p>
-          <a:p>
-            <a:pPr>
-              <a:defRPr sz="2000" b="1">
-                <a:solidFill>
-                  <a:srgbClr val="0F172A"/>
-                </a:solidFill>
-                <a:latin typeface="Arial"/>
-              </a:defRPr>
-            </a:pPr>
-            <a:r>
-              <a:rPr dirty="0"/>
-              <a:t>DEMO 15: </a:t>
-            </a:r>
-            <a:r>
-              <a:rPr dirty="0" err="1"/>
-              <a:t>Nạp</a:t>
-            </a:r>
-            <a:r>
-              <a:rPr dirty="0"/>
-              <a:t> </a:t>
-            </a:r>
-            <a:r>
-              <a:rPr dirty="0" err="1"/>
-              <a:t>Tiền</a:t>
-            </a:r>
-            <a:r>
-              <a:rPr dirty="0"/>
-              <a:t> </a:t>
-            </a:r>
-            <a:r>
-              <a:rPr dirty="0" err="1"/>
-              <a:t>Ví</a:t>
-            </a:r>
-            <a:r>
-              <a:rPr dirty="0"/>
-              <a:t> </a:t>
-            </a:r>
-            <a:r>
-              <a:rPr dirty="0" err="1"/>
-              <a:t>Điện</a:t>
-            </a:r>
-            <a:r>
-              <a:rPr dirty="0"/>
-              <a:t> </a:t>
-            </a:r>
-            <a:r>
-              <a:rPr dirty="0" err="1"/>
-              <a:t>Tử</a:t>
-            </a:r>
-            <a:r>
-              <a:rPr dirty="0"/>
-              <a:t> 2 Pha </a:t>
-            </a:r>
-            <a:r>
-              <a:rPr dirty="0" err="1"/>
-              <a:t>Chống</a:t>
-            </a:r>
-            <a:r>
-              <a:rPr dirty="0"/>
-              <a:t> Trùng Lặp </a:t>
-            </a:r>
-            <a:r>
-              <a:rPr lang="en-US" dirty="0"/>
-              <a:t>Cộng </a:t>
-            </a:r>
-            <a:r>
-              <a:rPr lang="en-US" dirty="0" err="1"/>
-              <a:t>Tiền</a:t>
-            </a:r>
-            <a:r>
-              <a:rPr lang="en-US" dirty="0"/>
-              <a:t> 2 </a:t>
-            </a:r>
-            <a:r>
-              <a:rPr lang="en-US" dirty="0" err="1"/>
-              <a:t>Lần</a:t>
-            </a:r>
-            <a:endParaRPr dirty="0"/>
-          </a:p>
-        </p:txBody>
-      </p:sp>
-      <p:sp>
-        <p:nvSpPr>
-          <p:cNvPr id="3" name="Rounded Rectangle 2"/>
-          <p:cNvSpPr/>
-          <p:nvPr/>
-        </p:nvSpPr>
-        <p:spPr>
-          <a:xfrm>
-            <a:off x="731520" y="1280160"/>
-            <a:ext cx="5180990" cy="4937760"/>
-          </a:xfrm>
-          <a:prstGeom prst="roundRect">
-            <a:avLst>
-              <a:gd name="adj" fmla="val 1500"/>
-            </a:avLst>
-          </a:prstGeom>
-          <a:solidFill>
-            <a:srgbClr val="FFFFFF"/>
-          </a:solidFill>
-          <a:ln w="12700">
-            <a:solidFill>
-              <a:srgbClr val="E2E8F0"/>
-            </a:solidFill>
-          </a:ln>
-        </p:spPr>
-        <p:style>
-          <a:lnRef idx="1">
-            <a:schemeClr val="accent1"/>
-          </a:lnRef>
-          <a:fillRef idx="3">
-            <a:schemeClr val="accent1"/>
-          </a:fillRef>
-          <a:effectRef idx="2">
-            <a:schemeClr val="accent1"/>
-          </a:effectRef>
-          <a:fontRef idx="minor">
-            <a:schemeClr val="lt1"/>
-          </a:fontRef>
-        </p:style>
-        <p:txBody>
-          <a:bodyPr rtlCol="0" anchor="ctr"/>
-          <a:lstStyle/>
-          <a:p>
-            <a:pPr algn="ctr"/>
-            <a:endParaRPr/>
-          </a:p>
-        </p:txBody>
-      </p:sp>
-      <p:sp>
-        <p:nvSpPr>
-          <p:cNvPr id="4" name="TextBox 3"/>
-          <p:cNvSpPr txBox="1"/>
-          <p:nvPr/>
-        </p:nvSpPr>
-        <p:spPr>
-          <a:xfrm>
-            <a:off x="960120" y="1508760"/>
-            <a:ext cx="4723790" cy="4480560"/>
-          </a:xfrm>
-          <a:prstGeom prst="rect">
-            <a:avLst/>
-          </a:prstGeom>
-          <a:noFill/>
-        </p:spPr>
-        <p:txBody>
-          <a:bodyPr wrap="square" lIns="0" tIns="0" rIns="0" bIns="0">
-            <a:spAutoFit/>
-          </a:bodyPr>
-          <a:lstStyle/>
-          <a:p>
-            <a:pPr>
-              <a:spcAft>
-                <a:spcPts val="1000"/>
-              </a:spcAft>
-              <a:defRPr sz="1500" b="1">
-                <a:solidFill>
-                  <a:srgbClr val="0284C7"/>
-                </a:solidFill>
-                <a:latin typeface="Arial"/>
-              </a:defRPr>
-            </a:pPr>
-            <a:r>
-              <a:t>🎯 BÀI TOÁN NGHIỆP VỤ</a:t>
-            </a:r>
-          </a:p>
-          <a:p>
-            <a:pPr>
-              <a:lnSpc>
-                <a:spcPct val="125000"/>
-              </a:lnSpc>
-              <a:defRPr sz="1250">
-                <a:solidFill>
-                  <a:srgbClr val="0F172A"/>
-                </a:solidFill>
-                <a:latin typeface="Arial"/>
-              </a:defRPr>
-            </a:pPr>
-            <a:r>
-              <a:t>Nạp tiền vào Ví qua cổng thanh toán (MoMo/VNPAY). Pha 1 tạo giao dịch 'Chờ xử lý'. Pha 2 xác nhận callback thành công và cộng tiền ví. Callback gửi lặp không bị cộng tiền 2 lần.</a:t>
-            </a:r>
-          </a:p>
-        </p:txBody>
-      </p:sp>
-      <p:sp>
-        <p:nvSpPr>
-          <p:cNvPr id="5" name="Rounded Rectangle 4"/>
-          <p:cNvSpPr/>
-          <p:nvPr/>
-        </p:nvSpPr>
-        <p:spPr>
-          <a:xfrm>
-            <a:off x="6278270" y="1280160"/>
-            <a:ext cx="5180990" cy="4937760"/>
-          </a:xfrm>
-          <a:prstGeom prst="roundRect">
-            <a:avLst>
-              <a:gd name="adj" fmla="val 1500"/>
-            </a:avLst>
-          </a:prstGeom>
-          <a:solidFill>
-            <a:srgbClr val="FFFFFF"/>
-          </a:solidFill>
-          <a:ln w="12700">
-            <a:solidFill>
-              <a:srgbClr val="E2E8F0"/>
-            </a:solidFill>
-          </a:ln>
-        </p:spPr>
-        <p:style>
-          <a:lnRef idx="1">
-            <a:schemeClr val="accent1"/>
-          </a:lnRef>
-          <a:fillRef idx="3">
-            <a:schemeClr val="accent1"/>
-          </a:fillRef>
-          <a:effectRef idx="2">
-            <a:schemeClr val="accent1"/>
-          </a:effectRef>
-          <a:fontRef idx="minor">
-            <a:schemeClr val="lt1"/>
-          </a:fontRef>
-        </p:style>
-        <p:txBody>
-          <a:bodyPr rtlCol="0" anchor="ctr"/>
-          <a:lstStyle/>
-          <a:p>
-            <a:pPr algn="ctr"/>
-            <a:endParaRPr/>
-          </a:p>
-        </p:txBody>
-      </p:sp>
-      <p:sp>
-        <p:nvSpPr>
-          <p:cNvPr id="6" name="TextBox 5"/>
-          <p:cNvSpPr txBox="1"/>
-          <p:nvPr/>
-        </p:nvSpPr>
-        <p:spPr>
-          <a:xfrm>
-            <a:off x="6506870" y="1508760"/>
-            <a:ext cx="4723790" cy="4480560"/>
-          </a:xfrm>
-          <a:prstGeom prst="rect">
-            <a:avLst/>
-          </a:prstGeom>
-          <a:noFill/>
-        </p:spPr>
-        <p:txBody>
-          <a:bodyPr wrap="square" lIns="0" tIns="0" rIns="0" bIns="0">
-            <a:spAutoFit/>
-          </a:bodyPr>
-          <a:lstStyle/>
-          <a:p>
-            <a:pPr>
-              <a:spcAft>
-                <a:spcPts val="1000"/>
-              </a:spcAft>
-              <a:defRPr sz="1400" b="1">
-                <a:solidFill>
-                  <a:srgbClr val="0F172A"/>
-                </a:solidFill>
-                <a:latin typeface="Arial"/>
-              </a:defRPr>
-            </a:pPr>
-            <a:r>
-              <a:t>🗄️ CÁC BẢNG DỮ LIỆU &amp; ĐỐI TƯỢNG CSDL LIÊN QUAN</a:t>
-            </a:r>
-          </a:p>
-          <a:p>
-            <a:pPr>
-              <a:spcAft>
-                <a:spcPts val="400"/>
-              </a:spcAft>
-              <a:defRPr sz="1200" b="1">
-                <a:solidFill>
-                  <a:srgbClr val="0F172A"/>
-                </a:solidFill>
-                <a:latin typeface="Arial"/>
-              </a:defRPr>
-            </a:pPr>
-            <a:r>
-              <a:t>• Các bảng dữ liệu bị ảnh hưởng / truy vấn:</a:t>
-            </a:r>
-          </a:p>
-          <a:p>
-            <a:pPr>
-              <a:spcAft>
-                <a:spcPts val="300"/>
-              </a:spcAft>
-              <a:defRPr sz="1150">
-                <a:solidFill>
-                  <a:srgbClr val="0F172A"/>
-                </a:solidFill>
-                <a:latin typeface="Arial"/>
-              </a:defRPr>
-            </a:pPr>
-            <a:r>
-              <a:t>    - GIAO_DICH (Ghi nhận trạng thái giao dịch nạp)</a:t>
-            </a:r>
-          </a:p>
-          <a:p>
-            <a:pPr>
-              <a:spcAft>
-                <a:spcPts val="300"/>
-              </a:spcAft>
-              <a:defRPr sz="1150">
-                <a:solidFill>
-                  <a:srgbClr val="0F172A"/>
-                </a:solidFill>
-                <a:latin typeface="Arial"/>
-              </a:defRPr>
-            </a:pPr>
-            <a:r>
-              <a:t>    - VI_DIEN_TU (Tự động cộng số dư ví khi thành công)</a:t>
-            </a:r>
-          </a:p>
-          <a:p>
-            <a:pPr>
-              <a:spcBef>
-                <a:spcPts val="800"/>
-              </a:spcBef>
-              <a:spcAft>
-                <a:spcPts val="400"/>
-              </a:spcAft>
-              <a:defRPr sz="1200" b="1">
-                <a:solidFill>
-                  <a:srgbClr val="0284C7"/>
-                </a:solidFill>
-                <a:latin typeface="Arial"/>
-              </a:defRPr>
-            </a:pPr>
-            <a:r>
-              <a:t>• Đối tượng T-SQL xử lý cốt lõi:</a:t>
-            </a:r>
-          </a:p>
-          <a:p>
-            <a:pPr>
-              <a:defRPr sz="1150" b="1">
-                <a:solidFill>
-                  <a:srgbClr val="0F172A"/>
-                </a:solidFill>
-                <a:latin typeface="Arial"/>
-              </a:defRPr>
-            </a:pPr>
-            <a:r>
-              <a:t>    Stored Procedure sp_KH_NapTien_KhoiTao + sp_KH_NapTien_XacNhan + Trigger trg_GiaoDich_CapNhatSoDu</a:t>
-            </a:r>
-          </a:p>
-        </p:txBody>
-      </p:sp>
-    </p:spTree>
-  </p:cSld>
-  <p:clrMapOvr>
-    <a:masterClrMapping/>
-  </p:clrMapOvr>
-</p:sld>
-</file>
-
-<file path=ppt/slides/slide19.xml><?xml version="1.0" encoding="utf-8"?>
-<p:sld xmlns:a="http://schemas.openxmlformats.org/drawingml/2006/main" xmlns:r="http://schemas.openxmlformats.org/officeDocument/2006/relationships" xmlns:p="http://schemas.openxmlformats.org/presentationml/2006/main">
-  <p:cSld>
-    <p:bg>
-      <p:bgPr>
-        <a:solidFill>
-          <a:srgbClr val="F8FAFC"/>
-        </a:solidFill>
-        <a:effectLst/>
-      </p:bgPr>
-    </p:bg>
-    <p:spTree>
-      <p:nvGrpSpPr>
-        <p:cNvPr id="1" name=""/>
-        <p:cNvGrpSpPr/>
-        <p:nvPr/>
-      </p:nvGrpSpPr>
-      <p:grpSpPr>
-        <a:xfrm>
-          <a:off x="0" y="0"/>
-          <a:ext cx="0" cy="0"/>
-          <a:chOff x="0" y="0"/>
-          <a:chExt cx="0" cy="0"/>
-        </a:xfrm>
-      </p:grpSpPr>
-      <p:sp>
-        <p:nvSpPr>
-          <p:cNvPr id="2" name="TextBox 1"/>
-          <p:cNvSpPr txBox="1"/>
-          <p:nvPr/>
-        </p:nvSpPr>
-        <p:spPr>
-          <a:xfrm>
-            <a:off x="731520" y="365760"/>
-            <a:ext cx="10728655" cy="822960"/>
-          </a:xfrm>
-          <a:prstGeom prst="rect">
-            <a:avLst/>
-          </a:prstGeom>
-          <a:noFill/>
-        </p:spPr>
-        <p:txBody>
-          <a:bodyPr wrap="square" lIns="0" tIns="0" rIns="0" bIns="0">
-            <a:spAutoFit/>
-          </a:bodyPr>
-          <a:lstStyle/>
-          <a:p>
-            <a:pPr>
-              <a:spcAft>
-                <a:spcPts val="200"/>
-              </a:spcAft>
-              <a:defRPr sz="1300" b="1">
-                <a:solidFill>
-                  <a:srgbClr val="0284C7"/>
-                </a:solidFill>
-                <a:latin typeface="Arial"/>
-              </a:defRPr>
-            </a:pPr>
-            <a:r>
-              <a:t>KỊCH BẢN DEMO #16 — KH-GIA-HAN-BANG-VI</a:t>
-            </a:r>
-          </a:p>
-          <a:p>
-            <a:pPr>
-              <a:defRPr sz="2000" b="1">
-                <a:solidFill>
-                  <a:srgbClr val="0F172A"/>
-                </a:solidFill>
-                <a:latin typeface="Arial"/>
-              </a:defRPr>
-            </a:pPr>
-            <a:r>
-              <a:t>DEMO 16: Khách Hàng Tự Gia Hạn Vé Tháng Bằng Ví Điện Tử</a:t>
-            </a:r>
-          </a:p>
-        </p:txBody>
-      </p:sp>
-      <p:sp>
-        <p:nvSpPr>
-          <p:cNvPr id="3" name="Rounded Rectangle 2"/>
-          <p:cNvSpPr/>
-          <p:nvPr/>
-        </p:nvSpPr>
-        <p:spPr>
-          <a:xfrm>
-            <a:off x="731520" y="1280160"/>
-            <a:ext cx="5180990" cy="4937760"/>
-          </a:xfrm>
-          <a:prstGeom prst="roundRect">
-            <a:avLst>
-              <a:gd name="adj" fmla="val 1500"/>
-            </a:avLst>
-          </a:prstGeom>
-          <a:solidFill>
-            <a:srgbClr val="FFFFFF"/>
-          </a:solidFill>
-          <a:ln w="12700">
-            <a:solidFill>
-              <a:srgbClr val="E2E8F0"/>
-            </a:solidFill>
-          </a:ln>
-        </p:spPr>
-        <p:style>
-          <a:lnRef idx="1">
-            <a:schemeClr val="accent1"/>
-          </a:lnRef>
-          <a:fillRef idx="3">
-            <a:schemeClr val="accent1"/>
-          </a:fillRef>
-          <a:effectRef idx="2">
-            <a:schemeClr val="accent1"/>
-          </a:effectRef>
-          <a:fontRef idx="minor">
-            <a:schemeClr val="lt1"/>
-          </a:fontRef>
-        </p:style>
-        <p:txBody>
-          <a:bodyPr rtlCol="0" anchor="ctr"/>
-          <a:lstStyle/>
-          <a:p>
-            <a:pPr algn="ctr"/>
-            <a:endParaRPr/>
-          </a:p>
-        </p:txBody>
-      </p:sp>
-      <p:sp>
-        <p:nvSpPr>
-          <p:cNvPr id="4" name="TextBox 3"/>
-          <p:cNvSpPr txBox="1"/>
-          <p:nvPr/>
-        </p:nvSpPr>
-        <p:spPr>
-          <a:xfrm>
-            <a:off x="960120" y="1508760"/>
-            <a:ext cx="4723790" cy="4480560"/>
-          </a:xfrm>
-          <a:prstGeom prst="rect">
-            <a:avLst/>
-          </a:prstGeom>
-          <a:noFill/>
-        </p:spPr>
-        <p:txBody>
-          <a:bodyPr wrap="square" lIns="0" tIns="0" rIns="0" bIns="0">
-            <a:spAutoFit/>
-          </a:bodyPr>
-          <a:lstStyle/>
-          <a:p>
-            <a:pPr>
-              <a:spcAft>
-                <a:spcPts val="1000"/>
-              </a:spcAft>
-              <a:defRPr sz="1500" b="1">
-                <a:solidFill>
-                  <a:srgbClr val="0284C7"/>
-                </a:solidFill>
-                <a:latin typeface="Arial"/>
-              </a:defRPr>
-            </a:pPr>
-            <a:r>
-              <a:t>🎯 BÀI TOÁN NGHIỆP VỤ</a:t>
-            </a:r>
-          </a:p>
-          <a:p>
-            <a:pPr>
-              <a:lnSpc>
-                <a:spcPct val="125000"/>
-              </a:lnSpc>
-              <a:defRPr sz="1250">
-                <a:solidFill>
-                  <a:srgbClr val="0F172A"/>
-                </a:solidFill>
-                <a:latin typeface="Arial"/>
-              </a:defRPr>
-            </a:pPr>
-            <a:r>
-              <a:t>Khách hàng trực tiếp gia hạn vé tháng trên Cổng online bằng số dư Ví điện tử. Hệ thống tự động trừ tiền ví, cộng thêm hạn vé và xuất hóa đơn gia hạn kênh 'Online'.</a:t>
-            </a:r>
-          </a:p>
-        </p:txBody>
-      </p:sp>
-      <p:sp>
-        <p:nvSpPr>
-          <p:cNvPr id="5" name="Rounded Rectangle 4"/>
-          <p:cNvSpPr/>
-          <p:nvPr/>
-        </p:nvSpPr>
-        <p:spPr>
-          <a:xfrm>
-            <a:off x="6278270" y="1280160"/>
-            <a:ext cx="5180990" cy="4937760"/>
-          </a:xfrm>
-          <a:prstGeom prst="roundRect">
-            <a:avLst>
-              <a:gd name="adj" fmla="val 1500"/>
-            </a:avLst>
-          </a:prstGeom>
-          <a:solidFill>
-            <a:srgbClr val="FFFFFF"/>
-          </a:solidFill>
-          <a:ln w="12700">
-            <a:solidFill>
-              <a:srgbClr val="E2E8F0"/>
-            </a:solidFill>
-          </a:ln>
-        </p:spPr>
-        <p:style>
-          <a:lnRef idx="1">
-            <a:schemeClr val="accent1"/>
-          </a:lnRef>
-          <a:fillRef idx="3">
-            <a:schemeClr val="accent1"/>
-          </a:fillRef>
-          <a:effectRef idx="2">
-            <a:schemeClr val="accent1"/>
-          </a:effectRef>
-          <a:fontRef idx="minor">
-            <a:schemeClr val="lt1"/>
-          </a:fontRef>
-        </p:style>
-        <p:txBody>
-          <a:bodyPr rtlCol="0" anchor="ctr"/>
-          <a:lstStyle/>
-          <a:p>
-            <a:pPr algn="ctr"/>
-            <a:endParaRPr/>
-          </a:p>
-        </p:txBody>
-      </p:sp>
-      <p:sp>
-        <p:nvSpPr>
-          <p:cNvPr id="6" name="TextBox 5"/>
-          <p:cNvSpPr txBox="1"/>
-          <p:nvPr/>
-        </p:nvSpPr>
-        <p:spPr>
-          <a:xfrm>
-            <a:off x="6506870" y="1508760"/>
-            <a:ext cx="4723790" cy="4480560"/>
-          </a:xfrm>
-          <a:prstGeom prst="rect">
-            <a:avLst/>
-          </a:prstGeom>
-          <a:noFill/>
-        </p:spPr>
-        <p:txBody>
-          <a:bodyPr wrap="square" lIns="0" tIns="0" rIns="0" bIns="0">
-            <a:spAutoFit/>
-          </a:bodyPr>
-          <a:lstStyle/>
-          <a:p>
-            <a:pPr>
-              <a:spcAft>
-                <a:spcPts val="1000"/>
-              </a:spcAft>
-              <a:defRPr sz="1400" b="1">
-                <a:solidFill>
-                  <a:srgbClr val="0F172A"/>
-                </a:solidFill>
-                <a:latin typeface="Arial"/>
-              </a:defRPr>
-            </a:pPr>
-            <a:r>
-              <a:t>🗄️ CÁC BẢNG DỮ LIỆU &amp; ĐỐI TƯỢNG CSDL LIÊN QUAN</a:t>
-            </a:r>
-          </a:p>
-          <a:p>
-            <a:pPr>
-              <a:spcAft>
-                <a:spcPts val="400"/>
-              </a:spcAft>
-              <a:defRPr sz="1200" b="1">
-                <a:solidFill>
-                  <a:srgbClr val="0F172A"/>
-                </a:solidFill>
-                <a:latin typeface="Arial"/>
-              </a:defRPr>
-            </a:pPr>
-            <a:r>
-              <a:t>• Các bảng dữ liệu bị ảnh hưởng / truy vấn:</a:t>
-            </a:r>
-          </a:p>
-          <a:p>
-            <a:pPr>
-              <a:spcAft>
-                <a:spcPts val="300"/>
-              </a:spcAft>
-              <a:defRPr sz="1150">
-                <a:solidFill>
-                  <a:srgbClr val="0F172A"/>
-                </a:solidFill>
-                <a:latin typeface="Arial"/>
-              </a:defRPr>
-            </a:pPr>
-            <a:r>
-              <a:t>    - VI_DIEN_TU (Trừ số dư ví)</a:t>
-            </a:r>
-          </a:p>
-          <a:p>
-            <a:pPr>
-              <a:spcAft>
-                <a:spcPts val="300"/>
-              </a:spcAft>
-              <a:defRPr sz="1150">
-                <a:solidFill>
-                  <a:srgbClr val="0F172A"/>
-                </a:solidFill>
-                <a:latin typeface="Arial"/>
-              </a:defRPr>
-            </a:pPr>
-            <a:r>
-              <a:t>    - VE_THANG (Cộng thêm 30 ngày vào ngày hết hạn)</a:t>
-            </a:r>
-          </a:p>
-          <a:p>
-            <a:pPr>
-              <a:spcAft>
-                <a:spcPts val="300"/>
-              </a:spcAft>
-              <a:defRPr sz="1150">
-                <a:solidFill>
-                  <a:srgbClr val="0F172A"/>
-                </a:solidFill>
-                <a:latin typeface="Arial"/>
-              </a:defRPr>
-            </a:pPr>
-            <a:r>
-              <a:t>    - HOA_DON_VE_THANG (Ghi nhận hóa đơn gia hạn online)</a:t>
-            </a:r>
-          </a:p>
-          <a:p>
-            <a:pPr>
-              <a:spcAft>
-                <a:spcPts val="300"/>
-              </a:spcAft>
-              <a:defRPr sz="1150">
-                <a:solidFill>
-                  <a:srgbClr val="0F172A"/>
-                </a:solidFill>
-                <a:latin typeface="Arial"/>
-              </a:defRPr>
-            </a:pPr>
-            <a:r>
-              <a:t>    - GIAO_DICH (Lịch sử trừ tiền ví)</a:t>
-            </a:r>
-          </a:p>
-          <a:p>
-            <a:pPr>
-              <a:spcBef>
-                <a:spcPts val="800"/>
-              </a:spcBef>
-              <a:spcAft>
-                <a:spcPts val="400"/>
-              </a:spcAft>
-              <a:defRPr sz="1200" b="1">
-                <a:solidFill>
-                  <a:srgbClr val="0284C7"/>
-                </a:solidFill>
-                <a:latin typeface="Arial"/>
-              </a:defRPr>
-            </a:pPr>
-            <a:r>
-              <a:t>• Đối tượng T-SQL xử lý cốt lõi:</a:t>
-            </a:r>
-          </a:p>
-          <a:p>
-            <a:pPr>
-              <a:defRPr sz="1150" b="1">
-                <a:solidFill>
-                  <a:srgbClr val="0F172A"/>
-                </a:solidFill>
-                <a:latin typeface="Arial"/>
-              </a:defRPr>
-            </a:pPr>
-            <a:r>
-              <a:t>    Stored Procedure sp_KH_GiaHanBangVi + sp_GiaHanVe_Core</a:t>
-            </a:r>
-          </a:p>
-        </p:txBody>
-      </p:sp>
-    </p:spTree>
-  </p:cSld>
-  <p:clrMapOvr>
-    <a:masterClrMapping/>
-  </p:clrMapOvr>
-</p:sld>
-</file>
-
 <file path=ppt/slides/slide2.xml><?xml version="1.0" encoding="utf-8"?>
 <p:sld xmlns:a="http://schemas.openxmlformats.org/drawingml/2006/main" xmlns:r="http://schemas.openxmlformats.org/officeDocument/2006/relationships" xmlns:p="http://schemas.openxmlformats.org/presentationml/2006/main">
   <p:cSld>
@@ -8947,1845 +7345,6 @@
             </a:pPr>
             <a:r>
               <a:t>Trần Phi Sơn</a:t>
-            </a:r>
-          </a:p>
-        </p:txBody>
-      </p:sp>
-    </p:spTree>
-  </p:cSld>
-  <p:clrMapOvr>
-    <a:masterClrMapping/>
-  </p:clrMapOvr>
-</p:sld>
-</file>
-
-<file path=ppt/slides/slide20.xml><?xml version="1.0" encoding="utf-8"?>
-<p:sld xmlns:a="http://schemas.openxmlformats.org/drawingml/2006/main" xmlns:r="http://schemas.openxmlformats.org/officeDocument/2006/relationships" xmlns:p="http://schemas.openxmlformats.org/presentationml/2006/main">
-  <p:cSld>
-    <p:bg>
-      <p:bgPr>
-        <a:solidFill>
-          <a:srgbClr val="F8FAFC"/>
-        </a:solidFill>
-        <a:effectLst/>
-      </p:bgPr>
-    </p:bg>
-    <p:spTree>
-      <p:nvGrpSpPr>
-        <p:cNvPr id="1" name=""/>
-        <p:cNvGrpSpPr/>
-        <p:nvPr/>
-      </p:nvGrpSpPr>
-      <p:grpSpPr>
-        <a:xfrm>
-          <a:off x="0" y="0"/>
-          <a:ext cx="0" cy="0"/>
-          <a:chOff x="0" y="0"/>
-          <a:chExt cx="0" cy="0"/>
-        </a:xfrm>
-      </p:grpSpPr>
-      <p:sp>
-        <p:nvSpPr>
-          <p:cNvPr id="2" name="TextBox 1"/>
-          <p:cNvSpPr txBox="1"/>
-          <p:nvPr/>
-        </p:nvSpPr>
-        <p:spPr>
-          <a:xfrm>
-            <a:off x="731520" y="365760"/>
-            <a:ext cx="10728655" cy="822960"/>
-          </a:xfrm>
-          <a:prstGeom prst="rect">
-            <a:avLst/>
-          </a:prstGeom>
-          <a:noFill/>
-        </p:spPr>
-        <p:txBody>
-          <a:bodyPr wrap="square" lIns="0" tIns="0" rIns="0" bIns="0">
-            <a:spAutoFit/>
-          </a:bodyPr>
-          <a:lstStyle/>
-          <a:p>
-            <a:pPr>
-              <a:spcAft>
-                <a:spcPts val="200"/>
-              </a:spcAft>
-              <a:defRPr sz="1300" b="1">
-                <a:solidFill>
-                  <a:srgbClr val="0284C7"/>
-                </a:solidFill>
-                <a:latin typeface="Arial"/>
-              </a:defRPr>
-            </a:pPr>
-            <a:r>
-              <a:t>KỊCH BẢN DEMO #17 — TRIGGER-CHAN-SO-DU-AM</a:t>
-            </a:r>
-          </a:p>
-          <a:p>
-            <a:pPr>
-              <a:defRPr sz="2000" b="1">
-                <a:solidFill>
-                  <a:srgbClr val="0F172A"/>
-                </a:solidFill>
-                <a:latin typeface="Arial"/>
-              </a:defRPr>
-            </a:pPr>
-            <a:r>
-              <a:t>DEMO 17: Trigger Chặn Giao Dịch Làm Âm Số Dư Ví Điện Tử</a:t>
-            </a:r>
-          </a:p>
-        </p:txBody>
-      </p:sp>
-      <p:sp>
-        <p:nvSpPr>
-          <p:cNvPr id="3" name="Rounded Rectangle 2"/>
-          <p:cNvSpPr/>
-          <p:nvPr/>
-        </p:nvSpPr>
-        <p:spPr>
-          <a:xfrm>
-            <a:off x="731520" y="1280160"/>
-            <a:ext cx="5180990" cy="4937760"/>
-          </a:xfrm>
-          <a:prstGeom prst="roundRect">
-            <a:avLst>
-              <a:gd name="adj" fmla="val 1500"/>
-            </a:avLst>
-          </a:prstGeom>
-          <a:solidFill>
-            <a:srgbClr val="FFFFFF"/>
-          </a:solidFill>
-          <a:ln w="12700">
-            <a:solidFill>
-              <a:srgbClr val="E2E8F0"/>
-            </a:solidFill>
-          </a:ln>
-        </p:spPr>
-        <p:style>
-          <a:lnRef idx="1">
-            <a:schemeClr val="accent1"/>
-          </a:lnRef>
-          <a:fillRef idx="3">
-            <a:schemeClr val="accent1"/>
-          </a:fillRef>
-          <a:effectRef idx="2">
-            <a:schemeClr val="accent1"/>
-          </a:effectRef>
-          <a:fontRef idx="minor">
-            <a:schemeClr val="lt1"/>
-          </a:fontRef>
-        </p:style>
-        <p:txBody>
-          <a:bodyPr rtlCol="0" anchor="ctr"/>
-          <a:lstStyle/>
-          <a:p>
-            <a:pPr algn="ctr"/>
-            <a:endParaRPr/>
-          </a:p>
-        </p:txBody>
-      </p:sp>
-      <p:sp>
-        <p:nvSpPr>
-          <p:cNvPr id="4" name="TextBox 3"/>
-          <p:cNvSpPr txBox="1"/>
-          <p:nvPr/>
-        </p:nvSpPr>
-        <p:spPr>
-          <a:xfrm>
-            <a:off x="960120" y="1508760"/>
-            <a:ext cx="4723790" cy="4480560"/>
-          </a:xfrm>
-          <a:prstGeom prst="rect">
-            <a:avLst/>
-          </a:prstGeom>
-          <a:noFill/>
-        </p:spPr>
-        <p:txBody>
-          <a:bodyPr wrap="square" lIns="0" tIns="0" rIns="0" bIns="0">
-            <a:spAutoFit/>
-          </a:bodyPr>
-          <a:lstStyle/>
-          <a:p>
-            <a:pPr>
-              <a:spcAft>
-                <a:spcPts val="1000"/>
-              </a:spcAft>
-              <a:defRPr sz="1500" b="1">
-                <a:solidFill>
-                  <a:srgbClr val="0284C7"/>
-                </a:solidFill>
-                <a:latin typeface="Arial"/>
-              </a:defRPr>
-            </a:pPr>
-            <a:r>
-              <a:t>🎯 BÀI TOÁN NGHIỆP VỤ</a:t>
-            </a:r>
-          </a:p>
-          <a:p>
-            <a:pPr>
-              <a:lnSpc>
-                <a:spcPct val="125000"/>
-              </a:lnSpc>
-              <a:defRPr sz="1250">
-                <a:solidFill>
-                  <a:srgbClr val="0F172A"/>
-                </a:solidFill>
-                <a:latin typeface="Arial"/>
-              </a:defRPr>
-            </a:pPr>
-            <a:r>
-              <a:t>Bảo vệ an toàn tài chính tuyệt đối. Ngăn chặn mọi giao dịch gia hạn hoặc rút tiền nếu số dư ví không đủ, đồng thời Trigger chặn mọi lệnh UPDATE trực tiếp làm thay đổi số dư ví.</a:t>
-            </a:r>
-          </a:p>
-        </p:txBody>
-      </p:sp>
-      <p:sp>
-        <p:nvSpPr>
-          <p:cNvPr id="5" name="Rounded Rectangle 4"/>
-          <p:cNvSpPr/>
-          <p:nvPr/>
-        </p:nvSpPr>
-        <p:spPr>
-          <a:xfrm>
-            <a:off x="6278270" y="1280160"/>
-            <a:ext cx="5180990" cy="4937760"/>
-          </a:xfrm>
-          <a:prstGeom prst="roundRect">
-            <a:avLst>
-              <a:gd name="adj" fmla="val 1500"/>
-            </a:avLst>
-          </a:prstGeom>
-          <a:solidFill>
-            <a:srgbClr val="FFFFFF"/>
-          </a:solidFill>
-          <a:ln w="12700">
-            <a:solidFill>
-              <a:srgbClr val="E2E8F0"/>
-            </a:solidFill>
-          </a:ln>
-        </p:spPr>
-        <p:style>
-          <a:lnRef idx="1">
-            <a:schemeClr val="accent1"/>
-          </a:lnRef>
-          <a:fillRef idx="3">
-            <a:schemeClr val="accent1"/>
-          </a:fillRef>
-          <a:effectRef idx="2">
-            <a:schemeClr val="accent1"/>
-          </a:effectRef>
-          <a:fontRef idx="minor">
-            <a:schemeClr val="lt1"/>
-          </a:fontRef>
-        </p:style>
-        <p:txBody>
-          <a:bodyPr rtlCol="0" anchor="ctr"/>
-          <a:lstStyle/>
-          <a:p>
-            <a:pPr algn="ctr"/>
-            <a:endParaRPr/>
-          </a:p>
-        </p:txBody>
-      </p:sp>
-      <p:sp>
-        <p:nvSpPr>
-          <p:cNvPr id="6" name="TextBox 5"/>
-          <p:cNvSpPr txBox="1"/>
-          <p:nvPr/>
-        </p:nvSpPr>
-        <p:spPr>
-          <a:xfrm>
-            <a:off x="6506870" y="1508760"/>
-            <a:ext cx="4723790" cy="4480560"/>
-          </a:xfrm>
-          <a:prstGeom prst="rect">
-            <a:avLst/>
-          </a:prstGeom>
-          <a:noFill/>
-        </p:spPr>
-        <p:txBody>
-          <a:bodyPr wrap="square" lIns="0" tIns="0" rIns="0" bIns="0">
-            <a:spAutoFit/>
-          </a:bodyPr>
-          <a:lstStyle/>
-          <a:p>
-            <a:pPr>
-              <a:spcAft>
-                <a:spcPts val="1000"/>
-              </a:spcAft>
-              <a:defRPr sz="1400" b="1">
-                <a:solidFill>
-                  <a:srgbClr val="0F172A"/>
-                </a:solidFill>
-                <a:latin typeface="Arial"/>
-              </a:defRPr>
-            </a:pPr>
-            <a:r>
-              <a:t>🗄️ CÁC BẢNG DỮ LIỆU &amp; ĐỐI TƯỢNG CSDL LIÊN QUAN</a:t>
-            </a:r>
-          </a:p>
-          <a:p>
-            <a:pPr>
-              <a:spcAft>
-                <a:spcPts val="400"/>
-              </a:spcAft>
-              <a:defRPr sz="1200" b="1">
-                <a:solidFill>
-                  <a:srgbClr val="0F172A"/>
-                </a:solidFill>
-                <a:latin typeface="Arial"/>
-              </a:defRPr>
-            </a:pPr>
-            <a:r>
-              <a:t>• Các bảng dữ liệu bị ảnh hưởng / truy vấn:</a:t>
-            </a:r>
-          </a:p>
-          <a:p>
-            <a:pPr>
-              <a:spcAft>
-                <a:spcPts val="300"/>
-              </a:spcAft>
-              <a:defRPr sz="1150">
-                <a:solidFill>
-                  <a:srgbClr val="0F172A"/>
-                </a:solidFill>
-                <a:latin typeface="Arial"/>
-              </a:defRPr>
-            </a:pPr>
-            <a:r>
-              <a:t>    - VI_DIEN_TU (Bảo vệ trường SoDu luôn &gt;= 0)</a:t>
-            </a:r>
-          </a:p>
-          <a:p>
-            <a:pPr>
-              <a:spcAft>
-                <a:spcPts val="300"/>
-              </a:spcAft>
-              <a:defRPr sz="1150">
-                <a:solidFill>
-                  <a:srgbClr val="0F172A"/>
-                </a:solidFill>
-                <a:latin typeface="Arial"/>
-              </a:defRPr>
-            </a:pPr>
-            <a:r>
-              <a:t>    - GIAO_DICH (ROLLBACK nếu giao dịch vi phạm)</a:t>
-            </a:r>
-          </a:p>
-          <a:p>
-            <a:pPr>
-              <a:spcBef>
-                <a:spcPts val="800"/>
-              </a:spcBef>
-              <a:spcAft>
-                <a:spcPts val="400"/>
-              </a:spcAft>
-              <a:defRPr sz="1200" b="1">
-                <a:solidFill>
-                  <a:srgbClr val="0284C7"/>
-                </a:solidFill>
-                <a:latin typeface="Arial"/>
-              </a:defRPr>
-            </a:pPr>
-            <a:r>
-              <a:t>• Đối tượng T-SQL xử lý cốt lõi:</a:t>
-            </a:r>
-          </a:p>
-          <a:p>
-            <a:pPr>
-              <a:defRPr sz="1150" b="1">
-                <a:solidFill>
-                  <a:srgbClr val="0F172A"/>
-                </a:solidFill>
-                <a:latin typeface="Arial"/>
-              </a:defRPr>
-            </a:pPr>
-            <a:r>
-              <a:t>    Trigger trg_ViDienTu_ChanSuaTrucTiep + Trigger Sổ cái (Mã lỗi 50031)</a:t>
-            </a:r>
-          </a:p>
-        </p:txBody>
-      </p:sp>
-    </p:spTree>
-  </p:cSld>
-  <p:clrMapOvr>
-    <a:masterClrMapping/>
-  </p:clrMapOvr>
-</p:sld>
-</file>
-
-<file path=ppt/slides/slide21.xml><?xml version="1.0" encoding="utf-8"?>
-<p:sld xmlns:a="http://schemas.openxmlformats.org/drawingml/2006/main" xmlns:r="http://schemas.openxmlformats.org/officeDocument/2006/relationships" xmlns:p="http://schemas.openxmlformats.org/presentationml/2006/main">
-  <p:cSld>
-    <p:bg>
-      <p:bgPr>
-        <a:solidFill>
-          <a:srgbClr val="F8FAFC"/>
-        </a:solidFill>
-        <a:effectLst/>
-      </p:bgPr>
-    </p:bg>
-    <p:spTree>
-      <p:nvGrpSpPr>
-        <p:cNvPr id="1" name=""/>
-        <p:cNvGrpSpPr/>
-        <p:nvPr/>
-      </p:nvGrpSpPr>
-      <p:grpSpPr>
-        <a:xfrm>
-          <a:off x="0" y="0"/>
-          <a:ext cx="0" cy="0"/>
-          <a:chOff x="0" y="0"/>
-          <a:chExt cx="0" cy="0"/>
-        </a:xfrm>
-      </p:grpSpPr>
-      <p:sp>
-        <p:nvSpPr>
-          <p:cNvPr id="2" name="TextBox 1"/>
-          <p:cNvSpPr txBox="1"/>
-          <p:nvPr/>
-        </p:nvSpPr>
-        <p:spPr>
-          <a:xfrm>
-            <a:off x="731520" y="365760"/>
-            <a:ext cx="10728655" cy="822960"/>
-          </a:xfrm>
-          <a:prstGeom prst="rect">
-            <a:avLst/>
-          </a:prstGeom>
-          <a:noFill/>
-        </p:spPr>
-        <p:txBody>
-          <a:bodyPr wrap="square" lIns="0" tIns="0" rIns="0" bIns="0">
-            <a:spAutoFit/>
-          </a:bodyPr>
-          <a:lstStyle/>
-          <a:p>
-            <a:pPr>
-              <a:spcAft>
-                <a:spcPts val="200"/>
-              </a:spcAft>
-              <a:defRPr sz="1300" b="1">
-                <a:solidFill>
-                  <a:srgbClr val="0284C7"/>
-                </a:solidFill>
-                <a:latin typeface="Arial"/>
-              </a:defRPr>
-            </a:pPr>
-            <a:r>
-              <a:t>KỊCH BẢN DEMO #18 — RLS-CO-LAP-DU-LIEU-KHACH-HANG</a:t>
-            </a:r>
-          </a:p>
-          <a:p>
-            <a:pPr>
-              <a:defRPr sz="2000" b="1">
-                <a:solidFill>
-                  <a:srgbClr val="0F172A"/>
-                </a:solidFill>
-                <a:latin typeface="Arial"/>
-              </a:defRPr>
-            </a:pPr>
-            <a:r>
-              <a:t>DEMO 18: Row-Level Security (RLS) Cô Lập Dữ Liệu Khách Hàng</a:t>
-            </a:r>
-          </a:p>
-        </p:txBody>
-      </p:sp>
-      <p:sp>
-        <p:nvSpPr>
-          <p:cNvPr id="3" name="Rounded Rectangle 2"/>
-          <p:cNvSpPr/>
-          <p:nvPr/>
-        </p:nvSpPr>
-        <p:spPr>
-          <a:xfrm>
-            <a:off x="731520" y="1280160"/>
-            <a:ext cx="5180990" cy="4937760"/>
-          </a:xfrm>
-          <a:prstGeom prst="roundRect">
-            <a:avLst>
-              <a:gd name="adj" fmla="val 1500"/>
-            </a:avLst>
-          </a:prstGeom>
-          <a:solidFill>
-            <a:srgbClr val="FFFFFF"/>
-          </a:solidFill>
-          <a:ln w="12700">
-            <a:solidFill>
-              <a:srgbClr val="E2E8F0"/>
-            </a:solidFill>
-          </a:ln>
-        </p:spPr>
-        <p:style>
-          <a:lnRef idx="1">
-            <a:schemeClr val="accent1"/>
-          </a:lnRef>
-          <a:fillRef idx="3">
-            <a:schemeClr val="accent1"/>
-          </a:fillRef>
-          <a:effectRef idx="2">
-            <a:schemeClr val="accent1"/>
-          </a:effectRef>
-          <a:fontRef idx="minor">
-            <a:schemeClr val="lt1"/>
-          </a:fontRef>
-        </p:style>
-        <p:txBody>
-          <a:bodyPr rtlCol="0" anchor="ctr"/>
-          <a:lstStyle/>
-          <a:p>
-            <a:pPr algn="ctr"/>
-            <a:endParaRPr/>
-          </a:p>
-        </p:txBody>
-      </p:sp>
-      <p:sp>
-        <p:nvSpPr>
-          <p:cNvPr id="4" name="TextBox 3"/>
-          <p:cNvSpPr txBox="1"/>
-          <p:nvPr/>
-        </p:nvSpPr>
-        <p:spPr>
-          <a:xfrm>
-            <a:off x="960120" y="1508760"/>
-            <a:ext cx="4723790" cy="4480560"/>
-          </a:xfrm>
-          <a:prstGeom prst="rect">
-            <a:avLst/>
-          </a:prstGeom>
-          <a:noFill/>
-        </p:spPr>
-        <p:txBody>
-          <a:bodyPr wrap="square" lIns="0" tIns="0" rIns="0" bIns="0">
-            <a:spAutoFit/>
-          </a:bodyPr>
-          <a:lstStyle/>
-          <a:p>
-            <a:pPr>
-              <a:spcAft>
-                <a:spcPts val="1000"/>
-              </a:spcAft>
-              <a:defRPr sz="1500" b="1">
-                <a:solidFill>
-                  <a:srgbClr val="0284C7"/>
-                </a:solidFill>
-                <a:latin typeface="Arial"/>
-              </a:defRPr>
-            </a:pPr>
-            <a:r>
-              <a:t>🎯 BÀI TOÁN NGHIỆP VỤ</a:t>
-            </a:r>
-          </a:p>
-          <a:p>
-            <a:pPr>
-              <a:lnSpc>
-                <a:spcPct val="125000"/>
-              </a:lnSpc>
-              <a:defRPr sz="1250">
-                <a:solidFill>
-                  <a:srgbClr val="0F172A"/>
-                </a:solidFill>
-                <a:latin typeface="Arial"/>
-              </a:defRPr>
-            </a:pPr>
-            <a:r>
-              <a:t>Bảo mật cấp CSDL. Đảm bảo mỗi khách hàng khi đăng nhập Cổng online chỉ truy vấn thấy dữ liệu giao dịch và ví của chính mình thông qua chính sách RLS lọc tự động theo SESSION_CONTEXT.</a:t>
-            </a:r>
-          </a:p>
-        </p:txBody>
-      </p:sp>
-      <p:sp>
-        <p:nvSpPr>
-          <p:cNvPr id="5" name="Rounded Rectangle 4"/>
-          <p:cNvSpPr/>
-          <p:nvPr/>
-        </p:nvSpPr>
-        <p:spPr>
-          <a:xfrm>
-            <a:off x="6278270" y="1280160"/>
-            <a:ext cx="5180990" cy="4937760"/>
-          </a:xfrm>
-          <a:prstGeom prst="roundRect">
-            <a:avLst>
-              <a:gd name="adj" fmla="val 1500"/>
-            </a:avLst>
-          </a:prstGeom>
-          <a:solidFill>
-            <a:srgbClr val="FFFFFF"/>
-          </a:solidFill>
-          <a:ln w="12700">
-            <a:solidFill>
-              <a:srgbClr val="E2E8F0"/>
-            </a:solidFill>
-          </a:ln>
-        </p:spPr>
-        <p:style>
-          <a:lnRef idx="1">
-            <a:schemeClr val="accent1"/>
-          </a:lnRef>
-          <a:fillRef idx="3">
-            <a:schemeClr val="accent1"/>
-          </a:fillRef>
-          <a:effectRef idx="2">
-            <a:schemeClr val="accent1"/>
-          </a:effectRef>
-          <a:fontRef idx="minor">
-            <a:schemeClr val="lt1"/>
-          </a:fontRef>
-        </p:style>
-        <p:txBody>
-          <a:bodyPr rtlCol="0" anchor="ctr"/>
-          <a:lstStyle/>
-          <a:p>
-            <a:pPr algn="ctr"/>
-            <a:endParaRPr/>
-          </a:p>
-        </p:txBody>
-      </p:sp>
-      <p:sp>
-        <p:nvSpPr>
-          <p:cNvPr id="6" name="TextBox 5"/>
-          <p:cNvSpPr txBox="1"/>
-          <p:nvPr/>
-        </p:nvSpPr>
-        <p:spPr>
-          <a:xfrm>
-            <a:off x="6506870" y="1508760"/>
-            <a:ext cx="4723790" cy="4480560"/>
-          </a:xfrm>
-          <a:prstGeom prst="rect">
-            <a:avLst/>
-          </a:prstGeom>
-          <a:noFill/>
-        </p:spPr>
-        <p:txBody>
-          <a:bodyPr wrap="square" lIns="0" tIns="0" rIns="0" bIns="0">
-            <a:spAutoFit/>
-          </a:bodyPr>
-          <a:lstStyle/>
-          <a:p>
-            <a:pPr>
-              <a:spcAft>
-                <a:spcPts val="1000"/>
-              </a:spcAft>
-              <a:defRPr sz="1400" b="1">
-                <a:solidFill>
-                  <a:srgbClr val="0F172A"/>
-                </a:solidFill>
-                <a:latin typeface="Arial"/>
-              </a:defRPr>
-            </a:pPr>
-            <a:r>
-              <a:t>🗄️ CÁC BẢNG DỮ LIỆU &amp; ĐỐI TƯỢNG CSDL LIÊN QUAN</a:t>
-            </a:r>
-          </a:p>
-          <a:p>
-            <a:pPr>
-              <a:spcAft>
-                <a:spcPts val="400"/>
-              </a:spcAft>
-              <a:defRPr sz="1200" b="1">
-                <a:solidFill>
-                  <a:srgbClr val="0F172A"/>
-                </a:solidFill>
-                <a:latin typeface="Arial"/>
-              </a:defRPr>
-            </a:pPr>
-            <a:r>
-              <a:t>• Các bảng dữ liệu bị ảnh hưởng / truy vấn:</a:t>
-            </a:r>
-          </a:p>
-          <a:p>
-            <a:pPr>
-              <a:spcAft>
-                <a:spcPts val="300"/>
-              </a:spcAft>
-              <a:defRPr sz="1150">
-                <a:solidFill>
-                  <a:srgbClr val="0F172A"/>
-                </a:solidFill>
-                <a:latin typeface="Arial"/>
-              </a:defRPr>
-            </a:pPr>
-            <a:r>
-              <a:t>    - GIAO_DICH (Áp dụng RLS lọc theo MaKH)</a:t>
-            </a:r>
-          </a:p>
-          <a:p>
-            <a:pPr>
-              <a:spcAft>
-                <a:spcPts val="300"/>
-              </a:spcAft>
-              <a:defRPr sz="1150">
-                <a:solidFill>
-                  <a:srgbClr val="0F172A"/>
-                </a:solidFill>
-                <a:latin typeface="Arial"/>
-              </a:defRPr>
-            </a:pPr>
-            <a:r>
-              <a:t>    - VI_DIEN_TU (Áp dụng RLS &amp; DENY bảng gốc)</a:t>
-            </a:r>
-          </a:p>
-          <a:p>
-            <a:pPr>
-              <a:spcAft>
-                <a:spcPts val="300"/>
-              </a:spcAft>
-              <a:defRPr sz="1150">
-                <a:solidFill>
-                  <a:srgbClr val="0F172A"/>
-                </a:solidFill>
-                <a:latin typeface="Arial"/>
-              </a:defRPr>
-            </a:pPr>
-            <a:r>
-              <a:t>    - vw_KH_LichSuGiaoDich (View an toàn cho khách)</a:t>
-            </a:r>
-          </a:p>
-          <a:p>
-            <a:pPr>
-              <a:spcBef>
-                <a:spcPts val="800"/>
-              </a:spcBef>
-              <a:spcAft>
-                <a:spcPts val="400"/>
-              </a:spcAft>
-              <a:defRPr sz="1200" b="1">
-                <a:solidFill>
-                  <a:srgbClr val="0284C7"/>
-                </a:solidFill>
-                <a:latin typeface="Arial"/>
-              </a:defRPr>
-            </a:pPr>
-            <a:r>
-              <a:t>• Đối tượng T-SQL xử lý cốt lõi:</a:t>
-            </a:r>
-          </a:p>
-          <a:p>
-            <a:pPr>
-              <a:defRPr sz="1150" b="1">
-                <a:solidFill>
-                  <a:srgbClr val="0F172A"/>
-                </a:solidFill>
-                <a:latin typeface="Arial"/>
-              </a:defRPr>
-            </a:pPr>
-            <a:r>
-              <a:t>    Security Policy bao_mat.rls_KhachHang + Predicate Function bao_mat.fn_rls_KhachHang / fn_rls_GiaoDich</a:t>
-            </a:r>
-          </a:p>
-        </p:txBody>
-      </p:sp>
-    </p:spTree>
-  </p:cSld>
-  <p:clrMapOvr>
-    <a:masterClrMapping/>
-  </p:clrMapOvr>
-</p:sld>
-</file>
-
-<file path=ppt/slides/slide22.xml><?xml version="1.0" encoding="utf-8"?>
-<p:sld xmlns:a="http://schemas.openxmlformats.org/drawingml/2006/main" xmlns:r="http://schemas.openxmlformats.org/officeDocument/2006/relationships" xmlns:p="http://schemas.openxmlformats.org/presentationml/2006/main">
-  <p:cSld>
-    <p:bg>
-      <p:bgPr>
-        <a:solidFill>
-          <a:srgbClr val="F8FAFC"/>
-        </a:solidFill>
-        <a:effectLst/>
-      </p:bgPr>
-    </p:bg>
-    <p:spTree>
-      <p:nvGrpSpPr>
-        <p:cNvPr id="1" name=""/>
-        <p:cNvGrpSpPr/>
-        <p:nvPr/>
-      </p:nvGrpSpPr>
-      <p:grpSpPr>
-        <a:xfrm>
-          <a:off x="0" y="0"/>
-          <a:ext cx="0" cy="0"/>
-          <a:chOff x="0" y="0"/>
-          <a:chExt cx="0" cy="0"/>
-        </a:xfrm>
-      </p:grpSpPr>
-      <p:sp>
-        <p:nvSpPr>
-          <p:cNvPr id="2" name="TextBox 1"/>
-          <p:cNvSpPr txBox="1"/>
-          <p:nvPr/>
-        </p:nvSpPr>
-        <p:spPr>
-          <a:xfrm>
-            <a:off x="731520" y="365760"/>
-            <a:ext cx="10728655" cy="822960"/>
-          </a:xfrm>
-          <a:prstGeom prst="rect">
-            <a:avLst/>
-          </a:prstGeom>
-          <a:noFill/>
-        </p:spPr>
-        <p:txBody>
-          <a:bodyPr wrap="square" lIns="0" tIns="0" rIns="0" bIns="0">
-            <a:spAutoFit/>
-          </a:bodyPr>
-          <a:lstStyle/>
-          <a:p>
-            <a:pPr>
-              <a:spcAft>
-                <a:spcPts val="200"/>
-              </a:spcAft>
-              <a:defRPr sz="1300" b="1">
-                <a:solidFill>
-                  <a:srgbClr val="0284C7"/>
-                </a:solidFill>
-                <a:latin typeface="Arial"/>
-              </a:defRPr>
-            </a:pPr>
-            <a:r>
-              <a:t>KỊCH BẢN DEMO #19 — KH-UY-QUYEN-VE</a:t>
-            </a:r>
-          </a:p>
-          <a:p>
-            <a:pPr>
-              <a:defRPr sz="2000" b="1">
-                <a:solidFill>
-                  <a:srgbClr val="0F172A"/>
-                </a:solidFill>
-                <a:latin typeface="Arial"/>
-              </a:defRPr>
-            </a:pPr>
-            <a:r>
-              <a:t>DEMO 19: Ủy Quyền &amp; Chia Sẻ Quyền Sử Dụng Vé Tháng</a:t>
-            </a:r>
-          </a:p>
-        </p:txBody>
-      </p:sp>
-      <p:sp>
-        <p:nvSpPr>
-          <p:cNvPr id="3" name="Rounded Rectangle 2"/>
-          <p:cNvSpPr/>
-          <p:nvPr/>
-        </p:nvSpPr>
-        <p:spPr>
-          <a:xfrm>
-            <a:off x="731520" y="1280160"/>
-            <a:ext cx="5180990" cy="4937760"/>
-          </a:xfrm>
-          <a:prstGeom prst="roundRect">
-            <a:avLst>
-              <a:gd name="adj" fmla="val 1500"/>
-            </a:avLst>
-          </a:prstGeom>
-          <a:solidFill>
-            <a:srgbClr val="FFFFFF"/>
-          </a:solidFill>
-          <a:ln w="12700">
-            <a:solidFill>
-              <a:srgbClr val="E2E8F0"/>
-            </a:solidFill>
-          </a:ln>
-        </p:spPr>
-        <p:style>
-          <a:lnRef idx="1">
-            <a:schemeClr val="accent1"/>
-          </a:lnRef>
-          <a:fillRef idx="3">
-            <a:schemeClr val="accent1"/>
-          </a:fillRef>
-          <a:effectRef idx="2">
-            <a:schemeClr val="accent1"/>
-          </a:effectRef>
-          <a:fontRef idx="minor">
-            <a:schemeClr val="lt1"/>
-          </a:fontRef>
-        </p:style>
-        <p:txBody>
-          <a:bodyPr rtlCol="0" anchor="ctr"/>
-          <a:lstStyle/>
-          <a:p>
-            <a:pPr algn="ctr"/>
-            <a:endParaRPr/>
-          </a:p>
-        </p:txBody>
-      </p:sp>
-      <p:sp>
-        <p:nvSpPr>
-          <p:cNvPr id="4" name="TextBox 3"/>
-          <p:cNvSpPr txBox="1"/>
-          <p:nvPr/>
-        </p:nvSpPr>
-        <p:spPr>
-          <a:xfrm>
-            <a:off x="960120" y="1508760"/>
-            <a:ext cx="4723790" cy="4480560"/>
-          </a:xfrm>
-          <a:prstGeom prst="rect">
-            <a:avLst/>
-          </a:prstGeom>
-          <a:noFill/>
-        </p:spPr>
-        <p:txBody>
-          <a:bodyPr wrap="square" lIns="0" tIns="0" rIns="0" bIns="0">
-            <a:spAutoFit/>
-          </a:bodyPr>
-          <a:lstStyle/>
-          <a:p>
-            <a:pPr>
-              <a:spcAft>
-                <a:spcPts val="1000"/>
-              </a:spcAft>
-              <a:defRPr sz="1500" b="1">
-                <a:solidFill>
-                  <a:srgbClr val="0284C7"/>
-                </a:solidFill>
-                <a:latin typeface="Arial"/>
-              </a:defRPr>
-            </a:pPr>
-            <a:r>
-              <a:t>🎯 BÀI TOÁN NGHIỆP VỤ</a:t>
-            </a:r>
-          </a:p>
-          <a:p>
-            <a:pPr>
-              <a:lnSpc>
-                <a:spcPct val="125000"/>
-              </a:lnSpc>
-              <a:defRPr sz="1250">
-                <a:solidFill>
-                  <a:srgbClr val="0F172A"/>
-                </a:solidFill>
-                <a:latin typeface="Arial"/>
-              </a:defRPr>
-            </a:pPr>
-            <a:r>
-              <a:t>Chủ vé chia sẻ quyền sử dụng vé tháng cho tối đa 3 người thân. Người được chia sẻ được dùng vé để gửi xe nhưng hệ thống chặn không cho phép thực hiện gia hạn vé.</a:t>
-            </a:r>
-          </a:p>
-        </p:txBody>
-      </p:sp>
-      <p:sp>
-        <p:nvSpPr>
-          <p:cNvPr id="5" name="Rounded Rectangle 4"/>
-          <p:cNvSpPr/>
-          <p:nvPr/>
-        </p:nvSpPr>
-        <p:spPr>
-          <a:xfrm>
-            <a:off x="6278270" y="1280160"/>
-            <a:ext cx="5180990" cy="4937760"/>
-          </a:xfrm>
-          <a:prstGeom prst="roundRect">
-            <a:avLst>
-              <a:gd name="adj" fmla="val 1500"/>
-            </a:avLst>
-          </a:prstGeom>
-          <a:solidFill>
-            <a:srgbClr val="FFFFFF"/>
-          </a:solidFill>
-          <a:ln w="12700">
-            <a:solidFill>
-              <a:srgbClr val="E2E8F0"/>
-            </a:solidFill>
-          </a:ln>
-        </p:spPr>
-        <p:style>
-          <a:lnRef idx="1">
-            <a:schemeClr val="accent1"/>
-          </a:lnRef>
-          <a:fillRef idx="3">
-            <a:schemeClr val="accent1"/>
-          </a:fillRef>
-          <a:effectRef idx="2">
-            <a:schemeClr val="accent1"/>
-          </a:effectRef>
-          <a:fontRef idx="minor">
-            <a:schemeClr val="lt1"/>
-          </a:fontRef>
-        </p:style>
-        <p:txBody>
-          <a:bodyPr rtlCol="0" anchor="ctr"/>
-          <a:lstStyle/>
-          <a:p>
-            <a:pPr algn="ctr"/>
-            <a:endParaRPr/>
-          </a:p>
-        </p:txBody>
-      </p:sp>
-      <p:sp>
-        <p:nvSpPr>
-          <p:cNvPr id="6" name="TextBox 5"/>
-          <p:cNvSpPr txBox="1"/>
-          <p:nvPr/>
-        </p:nvSpPr>
-        <p:spPr>
-          <a:xfrm>
-            <a:off x="6506870" y="1508760"/>
-            <a:ext cx="4723790" cy="4480560"/>
-          </a:xfrm>
-          <a:prstGeom prst="rect">
-            <a:avLst/>
-          </a:prstGeom>
-          <a:noFill/>
-        </p:spPr>
-        <p:txBody>
-          <a:bodyPr wrap="square" lIns="0" tIns="0" rIns="0" bIns="0">
-            <a:spAutoFit/>
-          </a:bodyPr>
-          <a:lstStyle/>
-          <a:p>
-            <a:pPr>
-              <a:spcAft>
-                <a:spcPts val="1000"/>
-              </a:spcAft>
-              <a:defRPr sz="1400" b="1">
-                <a:solidFill>
-                  <a:srgbClr val="0F172A"/>
-                </a:solidFill>
-                <a:latin typeface="Arial"/>
-              </a:defRPr>
-            </a:pPr>
-            <a:r>
-              <a:t>🗄️ CÁC BẢNG DỮ LIỆU &amp; ĐỐI TƯỢNG CSDL LIÊN QUAN</a:t>
-            </a:r>
-          </a:p>
-          <a:p>
-            <a:pPr>
-              <a:spcAft>
-                <a:spcPts val="400"/>
-              </a:spcAft>
-              <a:defRPr sz="1200" b="1">
-                <a:solidFill>
-                  <a:srgbClr val="0F172A"/>
-                </a:solidFill>
-                <a:latin typeface="Arial"/>
-              </a:defRPr>
-            </a:pPr>
-            <a:r>
-              <a:t>• Các bảng dữ liệu bị ảnh hưởng / truy vấn:</a:t>
-            </a:r>
-          </a:p>
-          <a:p>
-            <a:pPr>
-              <a:spcAft>
-                <a:spcPts val="300"/>
-              </a:spcAft>
-              <a:defRPr sz="1150">
-                <a:solidFill>
-                  <a:srgbClr val="0F172A"/>
-                </a:solidFill>
-                <a:latin typeface="Arial"/>
-              </a:defRPr>
-            </a:pPr>
-            <a:r>
-              <a:t>    - UY_QUYEN_VE (Lưu thông tin ủy quyền chia sẻ vé)</a:t>
-            </a:r>
-          </a:p>
-          <a:p>
-            <a:pPr>
-              <a:spcAft>
-                <a:spcPts val="300"/>
-              </a:spcAft>
-              <a:defRPr sz="1150">
-                <a:solidFill>
-                  <a:srgbClr val="0F172A"/>
-                </a:solidFill>
-                <a:latin typeface="Arial"/>
-              </a:defRPr>
-            </a:pPr>
-            <a:r>
-              <a:t>    - VE_THANG (Đối chiếu quyền chủ sở hữu)</a:t>
-            </a:r>
-          </a:p>
-          <a:p>
-            <a:pPr>
-              <a:spcAft>
-                <a:spcPts val="300"/>
-              </a:spcAft>
-              <a:defRPr sz="1150">
-                <a:solidFill>
-                  <a:srgbClr val="0F172A"/>
-                </a:solidFill>
-                <a:latin typeface="Arial"/>
-              </a:defRPr>
-            </a:pPr>
-            <a:r>
-              <a:t>    - TAI_KHOAN_KH (Tài khoản người nhận ủy quyền)</a:t>
-            </a:r>
-          </a:p>
-          <a:p>
-            <a:pPr>
-              <a:spcBef>
-                <a:spcPts val="800"/>
-              </a:spcBef>
-              <a:spcAft>
-                <a:spcPts val="400"/>
-              </a:spcAft>
-              <a:defRPr sz="1200" b="1">
-                <a:solidFill>
-                  <a:srgbClr val="0284C7"/>
-                </a:solidFill>
-                <a:latin typeface="Arial"/>
-              </a:defRPr>
-            </a:pPr>
-            <a:r>
-              <a:t>• Đối tượng T-SQL xử lý cốt lõi:</a:t>
-            </a:r>
-          </a:p>
-          <a:p>
-            <a:pPr>
-              <a:defRPr sz="1150" b="1">
-                <a:solidFill>
-                  <a:srgbClr val="0F172A"/>
-                </a:solidFill>
-                <a:latin typeface="Arial"/>
-              </a:defRPr>
-            </a:pPr>
-            <a:r>
-              <a:t>    Stored Procedure sp_KH_UyQuyenVe + Function f_KH_CoQuyen (Mã lỗi 50050 / 50053)</a:t>
-            </a:r>
-          </a:p>
-        </p:txBody>
-      </p:sp>
-    </p:spTree>
-  </p:cSld>
-  <p:clrMapOvr>
-    <a:masterClrMapping/>
-  </p:clrMapOvr>
-</p:sld>
-</file>
-
-<file path=ppt/slides/slide23.xml><?xml version="1.0" encoding="utf-8"?>
-<p:sld xmlns:a="http://schemas.openxmlformats.org/drawingml/2006/main" xmlns:r="http://schemas.openxmlformats.org/officeDocument/2006/relationships" xmlns:p="http://schemas.openxmlformats.org/presentationml/2006/main">
-  <p:cSld>
-    <p:bg>
-      <p:bgPr>
-        <a:solidFill>
-          <a:srgbClr val="F8FAFC"/>
-        </a:solidFill>
-        <a:effectLst/>
-      </p:bgPr>
-    </p:bg>
-    <p:spTree>
-      <p:nvGrpSpPr>
-        <p:cNvPr id="1" name=""/>
-        <p:cNvGrpSpPr/>
-        <p:nvPr/>
-      </p:nvGrpSpPr>
-      <p:grpSpPr>
-        <a:xfrm>
-          <a:off x="0" y="0"/>
-          <a:ext cx="0" cy="0"/>
-          <a:chOff x="0" y="0"/>
-          <a:chExt cx="0" cy="0"/>
-        </a:xfrm>
-      </p:grpSpPr>
-      <p:sp>
-        <p:nvSpPr>
-          <p:cNvPr id="2" name="TextBox 1"/>
-          <p:cNvSpPr txBox="1"/>
-          <p:nvPr/>
-        </p:nvSpPr>
-        <p:spPr>
-          <a:xfrm>
-            <a:off x="731520" y="365760"/>
-            <a:ext cx="10728655" cy="822960"/>
-          </a:xfrm>
-          <a:prstGeom prst="rect">
-            <a:avLst/>
-          </a:prstGeom>
-          <a:noFill/>
-        </p:spPr>
-        <p:txBody>
-          <a:bodyPr wrap="square" lIns="0" tIns="0" rIns="0" bIns="0">
-            <a:spAutoFit/>
-          </a:bodyPr>
-          <a:lstStyle/>
-          <a:p>
-            <a:pPr>
-              <a:spcAft>
-                <a:spcPts val="200"/>
-              </a:spcAft>
-              <a:defRPr sz="1300" b="1">
-                <a:solidFill>
-                  <a:srgbClr val="0284C7"/>
-                </a:solidFill>
-                <a:latin typeface="Arial"/>
-              </a:defRPr>
-            </a:pPr>
-            <a:r>
-              <a:t>KỊCH BẢN DEMO #20 — CURSOR-TU-DONG-GIA-HAN</a:t>
-            </a:r>
-          </a:p>
-          <a:p>
-            <a:pPr>
-              <a:defRPr sz="2000" b="1">
-                <a:solidFill>
-                  <a:srgbClr val="0F172A"/>
-                </a:solidFill>
-                <a:latin typeface="Arial"/>
-              </a:defRPr>
-            </a:pPr>
-            <a:r>
-              <a:t>DEMO 20: Cursor Tự Động Gia Hạn Trong Savepoint Riêng Biệt</a:t>
-            </a:r>
-          </a:p>
-        </p:txBody>
-      </p:sp>
-      <p:sp>
-        <p:nvSpPr>
-          <p:cNvPr id="3" name="Rounded Rectangle 2"/>
-          <p:cNvSpPr/>
-          <p:nvPr/>
-        </p:nvSpPr>
-        <p:spPr>
-          <a:xfrm>
-            <a:off x="731520" y="1280160"/>
-            <a:ext cx="5180990" cy="4937760"/>
-          </a:xfrm>
-          <a:prstGeom prst="roundRect">
-            <a:avLst>
-              <a:gd name="adj" fmla="val 1500"/>
-            </a:avLst>
-          </a:prstGeom>
-          <a:solidFill>
-            <a:srgbClr val="FFFFFF"/>
-          </a:solidFill>
-          <a:ln w="12700">
-            <a:solidFill>
-              <a:srgbClr val="E2E8F0"/>
-            </a:solidFill>
-          </a:ln>
-        </p:spPr>
-        <p:style>
-          <a:lnRef idx="1">
-            <a:schemeClr val="accent1"/>
-          </a:lnRef>
-          <a:fillRef idx="3">
-            <a:schemeClr val="accent1"/>
-          </a:fillRef>
-          <a:effectRef idx="2">
-            <a:schemeClr val="accent1"/>
-          </a:effectRef>
-          <a:fontRef idx="minor">
-            <a:schemeClr val="lt1"/>
-          </a:fontRef>
-        </p:style>
-        <p:txBody>
-          <a:bodyPr rtlCol="0" anchor="ctr"/>
-          <a:lstStyle/>
-          <a:p>
-            <a:pPr algn="ctr"/>
-            <a:endParaRPr/>
-          </a:p>
-        </p:txBody>
-      </p:sp>
-      <p:sp>
-        <p:nvSpPr>
-          <p:cNvPr id="4" name="TextBox 3"/>
-          <p:cNvSpPr txBox="1"/>
-          <p:nvPr/>
-        </p:nvSpPr>
-        <p:spPr>
-          <a:xfrm>
-            <a:off x="960120" y="1508760"/>
-            <a:ext cx="4723790" cy="4480560"/>
-          </a:xfrm>
-          <a:prstGeom prst="rect">
-            <a:avLst/>
-          </a:prstGeom>
-          <a:noFill/>
-        </p:spPr>
-        <p:txBody>
-          <a:bodyPr wrap="square" lIns="0" tIns="0" rIns="0" bIns="0">
-            <a:spAutoFit/>
-          </a:bodyPr>
-          <a:lstStyle/>
-          <a:p>
-            <a:pPr>
-              <a:spcAft>
-                <a:spcPts val="1000"/>
-              </a:spcAft>
-              <a:defRPr sz="1500" b="1">
-                <a:solidFill>
-                  <a:srgbClr val="0284C7"/>
-                </a:solidFill>
-                <a:latin typeface="Arial"/>
-              </a:defRPr>
-            </a:pPr>
-            <a:r>
-              <a:t>🎯 BÀI TOÁN NGHIỆP VỤ</a:t>
-            </a:r>
-          </a:p>
-          <a:p>
-            <a:pPr>
-              <a:lnSpc>
-                <a:spcPct val="125000"/>
-              </a:lnSpc>
-              <a:defRPr sz="1250">
-                <a:solidFill>
-                  <a:srgbClr val="0F172A"/>
-                </a:solidFill>
-                <a:latin typeface="Arial"/>
-              </a:defRPr>
-            </a:pPr>
-            <a:r>
-              <a:t>Cursor xử lý các vé đăng ký 'Tự động gia hạn'. Mỗi vé được chạy trong 1 SAVEPOINT riêng biệt: nếu 1 vé thất bại do thiếu tiền ví thì chỉ ROLLBACK vé đó, không làm hủy các vé khác.</a:t>
-            </a:r>
-          </a:p>
-        </p:txBody>
-      </p:sp>
-      <p:sp>
-        <p:nvSpPr>
-          <p:cNvPr id="5" name="Rounded Rectangle 4"/>
-          <p:cNvSpPr/>
-          <p:nvPr/>
-        </p:nvSpPr>
-        <p:spPr>
-          <a:xfrm>
-            <a:off x="6278270" y="1280160"/>
-            <a:ext cx="5180990" cy="4937760"/>
-          </a:xfrm>
-          <a:prstGeom prst="roundRect">
-            <a:avLst>
-              <a:gd name="adj" fmla="val 1500"/>
-            </a:avLst>
-          </a:prstGeom>
-          <a:solidFill>
-            <a:srgbClr val="FFFFFF"/>
-          </a:solidFill>
-          <a:ln w="12700">
-            <a:solidFill>
-              <a:srgbClr val="E2E8F0"/>
-            </a:solidFill>
-          </a:ln>
-        </p:spPr>
-        <p:style>
-          <a:lnRef idx="1">
-            <a:schemeClr val="accent1"/>
-          </a:lnRef>
-          <a:fillRef idx="3">
-            <a:schemeClr val="accent1"/>
-          </a:fillRef>
-          <a:effectRef idx="2">
-            <a:schemeClr val="accent1"/>
-          </a:effectRef>
-          <a:fontRef idx="minor">
-            <a:schemeClr val="lt1"/>
-          </a:fontRef>
-        </p:style>
-        <p:txBody>
-          <a:bodyPr rtlCol="0" anchor="ctr"/>
-          <a:lstStyle/>
-          <a:p>
-            <a:pPr algn="ctr"/>
-            <a:endParaRPr/>
-          </a:p>
-        </p:txBody>
-      </p:sp>
-      <p:sp>
-        <p:nvSpPr>
-          <p:cNvPr id="6" name="TextBox 5"/>
-          <p:cNvSpPr txBox="1"/>
-          <p:nvPr/>
-        </p:nvSpPr>
-        <p:spPr>
-          <a:xfrm>
-            <a:off x="6506870" y="1508760"/>
-            <a:ext cx="4723790" cy="4480560"/>
-          </a:xfrm>
-          <a:prstGeom prst="rect">
-            <a:avLst/>
-          </a:prstGeom>
-          <a:noFill/>
-        </p:spPr>
-        <p:txBody>
-          <a:bodyPr wrap="square" lIns="0" tIns="0" rIns="0" bIns="0">
-            <a:spAutoFit/>
-          </a:bodyPr>
-          <a:lstStyle/>
-          <a:p>
-            <a:pPr>
-              <a:spcAft>
-                <a:spcPts val="1000"/>
-              </a:spcAft>
-              <a:defRPr sz="1400" b="1">
-                <a:solidFill>
-                  <a:srgbClr val="0F172A"/>
-                </a:solidFill>
-                <a:latin typeface="Arial"/>
-              </a:defRPr>
-            </a:pPr>
-            <a:r>
-              <a:t>🗄️ CÁC BẢNG DỮ LIỆU &amp; ĐỐI TƯỢNG CSDL LIÊN QUAN</a:t>
-            </a:r>
-          </a:p>
-          <a:p>
-            <a:pPr>
-              <a:spcAft>
-                <a:spcPts val="400"/>
-              </a:spcAft>
-              <a:defRPr sz="1200" b="1">
-                <a:solidFill>
-                  <a:srgbClr val="0F172A"/>
-                </a:solidFill>
-                <a:latin typeface="Arial"/>
-              </a:defRPr>
-            </a:pPr>
-            <a:r>
-              <a:t>• Các bảng dữ liệu bị ảnh hưởng / truy vấn:</a:t>
-            </a:r>
-          </a:p>
-          <a:p>
-            <a:pPr>
-              <a:spcAft>
-                <a:spcPts val="300"/>
-              </a:spcAft>
-              <a:defRPr sz="1150">
-                <a:solidFill>
-                  <a:srgbClr val="0F172A"/>
-                </a:solidFill>
-                <a:latin typeface="Arial"/>
-              </a:defRPr>
-            </a:pPr>
-            <a:r>
-              <a:t>    - VE_THANG (Gia hạn thời gian hiệu lực)</a:t>
-            </a:r>
-          </a:p>
-          <a:p>
-            <a:pPr>
-              <a:spcAft>
-                <a:spcPts val="300"/>
-              </a:spcAft>
-              <a:defRPr sz="1150">
-                <a:solidFill>
-                  <a:srgbClr val="0F172A"/>
-                </a:solidFill>
-                <a:latin typeface="Arial"/>
-              </a:defRPr>
-            </a:pPr>
-            <a:r>
-              <a:t>    - HOA_DON_VE_THANG (Xuất hóa đơn kênh 'Tự động')</a:t>
-            </a:r>
-          </a:p>
-          <a:p>
-            <a:pPr>
-              <a:spcAft>
-                <a:spcPts val="300"/>
-              </a:spcAft>
-              <a:defRPr sz="1150">
-                <a:solidFill>
-                  <a:srgbClr val="0F172A"/>
-                </a:solidFill>
-                <a:latin typeface="Arial"/>
-              </a:defRPr>
-            </a:pPr>
-            <a:r>
-              <a:t>    - VI_DIEN_TU (Tự động trừ số dư ví)</a:t>
-            </a:r>
-          </a:p>
-          <a:p>
-            <a:pPr>
-              <a:spcBef>
-                <a:spcPts val="800"/>
-              </a:spcBef>
-              <a:spcAft>
-                <a:spcPts val="400"/>
-              </a:spcAft>
-              <a:defRPr sz="1200" b="1">
-                <a:solidFill>
-                  <a:srgbClr val="0284C7"/>
-                </a:solidFill>
-                <a:latin typeface="Arial"/>
-              </a:defRPr>
-            </a:pPr>
-            <a:r>
-              <a:t>• Đối tượng T-SQL xử lý cốt lõi:</a:t>
-            </a:r>
-          </a:p>
-          <a:p>
-            <a:pPr>
-              <a:defRPr sz="1150" b="1">
-                <a:solidFill>
-                  <a:srgbClr val="0F172A"/>
-                </a:solidFill>
-                <a:latin typeface="Arial"/>
-              </a:defRPr>
-            </a:pPr>
-            <a:r>
-              <a:t>    Cursor Procedure sp_DemoCanhBaoHanTheThang (Sử dụng SAVE TRANSACTION)</a:t>
-            </a:r>
-          </a:p>
-        </p:txBody>
-      </p:sp>
-    </p:spTree>
-  </p:cSld>
-  <p:clrMapOvr>
-    <a:masterClrMapping/>
-  </p:clrMapOvr>
-</p:sld>
-</file>
-
-<file path=ppt/slides/slide24.xml><?xml version="1.0" encoding="utf-8"?>
-<p:sld xmlns:a="http://schemas.openxmlformats.org/drawingml/2006/main" xmlns:r="http://schemas.openxmlformats.org/officeDocument/2006/relationships" xmlns:p="http://schemas.openxmlformats.org/presentationml/2006/main">
-  <p:cSld>
-    <p:bg>
-      <p:bgPr>
-        <a:solidFill>
-          <a:srgbClr val="F8FAFC"/>
-        </a:solidFill>
-        <a:effectLst/>
-      </p:bgPr>
-    </p:bg>
-    <p:spTree>
-      <p:nvGrpSpPr>
-        <p:cNvPr id="1" name=""/>
-        <p:cNvGrpSpPr/>
-        <p:nvPr/>
-      </p:nvGrpSpPr>
-      <p:grpSpPr>
-        <a:xfrm>
-          <a:off x="0" y="0"/>
-          <a:ext cx="0" cy="0"/>
-          <a:chOff x="0" y="0"/>
-          <a:chExt cx="0" cy="0"/>
-        </a:xfrm>
-      </p:grpSpPr>
-      <p:sp>
-        <p:nvSpPr>
-          <p:cNvPr id="2" name="TextBox 1"/>
-          <p:cNvSpPr txBox="1"/>
-          <p:nvPr/>
-        </p:nvSpPr>
-        <p:spPr>
-          <a:xfrm>
-            <a:off x="731520" y="365760"/>
-            <a:ext cx="10728655" cy="822960"/>
-          </a:xfrm>
-          <a:prstGeom prst="rect">
-            <a:avLst/>
-          </a:prstGeom>
-          <a:noFill/>
-        </p:spPr>
-        <p:txBody>
-          <a:bodyPr wrap="square" lIns="0" tIns="0" rIns="0" bIns="0">
-            <a:spAutoFit/>
-          </a:bodyPr>
-          <a:lstStyle/>
-          <a:p>
-            <a:pPr>
-              <a:spcAft>
-                <a:spcPts val="200"/>
-              </a:spcAft>
-              <a:defRPr sz="1300" b="1">
-                <a:solidFill>
-                  <a:srgbClr val="0284C7"/>
-                </a:solidFill>
-                <a:latin typeface="Arial"/>
-              </a:defRPr>
-            </a:pPr>
-            <a:r>
-              <a:t>KỊCH BẢN DEMO #21 — TRIGGER-SO-CAI-BAT-BIEN</a:t>
-            </a:r>
-          </a:p>
-          <a:p>
-            <a:pPr>
-              <a:defRPr sz="2000" b="1">
-                <a:solidFill>
-                  <a:srgbClr val="0F172A"/>
-                </a:solidFill>
-                <a:latin typeface="Arial"/>
-              </a:defRPr>
-            </a:pPr>
-            <a:r>
-              <a:t>DEMO 21: Trigger Bảo Vệ Sổ Cái Tài Chính Bất Biến Append-Only</a:t>
-            </a:r>
-          </a:p>
-        </p:txBody>
-      </p:sp>
-      <p:sp>
-        <p:nvSpPr>
-          <p:cNvPr id="3" name="Rounded Rectangle 2"/>
-          <p:cNvSpPr/>
-          <p:nvPr/>
-        </p:nvSpPr>
-        <p:spPr>
-          <a:xfrm>
-            <a:off x="731520" y="1280160"/>
-            <a:ext cx="5180990" cy="4937760"/>
-          </a:xfrm>
-          <a:prstGeom prst="roundRect">
-            <a:avLst>
-              <a:gd name="adj" fmla="val 1500"/>
-            </a:avLst>
-          </a:prstGeom>
-          <a:solidFill>
-            <a:srgbClr val="FFFFFF"/>
-          </a:solidFill>
-          <a:ln w="12700">
-            <a:solidFill>
-              <a:srgbClr val="E2E8F0"/>
-            </a:solidFill>
-          </a:ln>
-        </p:spPr>
-        <p:style>
-          <a:lnRef idx="1">
-            <a:schemeClr val="accent1"/>
-          </a:lnRef>
-          <a:fillRef idx="3">
-            <a:schemeClr val="accent1"/>
-          </a:fillRef>
-          <a:effectRef idx="2">
-            <a:schemeClr val="accent1"/>
-          </a:effectRef>
-          <a:fontRef idx="minor">
-            <a:schemeClr val="lt1"/>
-          </a:fontRef>
-        </p:style>
-        <p:txBody>
-          <a:bodyPr rtlCol="0" anchor="ctr"/>
-          <a:lstStyle/>
-          <a:p>
-            <a:pPr algn="ctr"/>
-            <a:endParaRPr/>
-          </a:p>
-        </p:txBody>
-      </p:sp>
-      <p:sp>
-        <p:nvSpPr>
-          <p:cNvPr id="4" name="TextBox 3"/>
-          <p:cNvSpPr txBox="1"/>
-          <p:nvPr/>
-        </p:nvSpPr>
-        <p:spPr>
-          <a:xfrm>
-            <a:off x="960120" y="1508760"/>
-            <a:ext cx="4723790" cy="4480560"/>
-          </a:xfrm>
-          <a:prstGeom prst="rect">
-            <a:avLst/>
-          </a:prstGeom>
-          <a:noFill/>
-        </p:spPr>
-        <p:txBody>
-          <a:bodyPr wrap="square" lIns="0" tIns="0" rIns="0" bIns="0">
-            <a:spAutoFit/>
-          </a:bodyPr>
-          <a:lstStyle/>
-          <a:p>
-            <a:pPr>
-              <a:spcAft>
-                <a:spcPts val="1000"/>
-              </a:spcAft>
-              <a:defRPr sz="1500" b="1">
-                <a:solidFill>
-                  <a:srgbClr val="0284C7"/>
-                </a:solidFill>
-                <a:latin typeface="Arial"/>
-              </a:defRPr>
-            </a:pPr>
-            <a:r>
-              <a:t>🎯 BÀI TOÁN NGHIỆP VỤ</a:t>
-            </a:r>
-          </a:p>
-          <a:p>
-            <a:pPr>
-              <a:lnSpc>
-                <a:spcPct val="125000"/>
-              </a:lnSpc>
-              <a:defRPr sz="1250">
-                <a:solidFill>
-                  <a:srgbClr val="0F172A"/>
-                </a:solidFill>
-                <a:latin typeface="Arial"/>
-              </a:defRPr>
-            </a:pPr>
-            <a:r>
-              <a:t>Đảm bảo tính minh bạch kế toán. Mọi giao dịch ghi nhận dạng Append-Only; Trigger chặn vĩnh viễn mọi hành vi sửa tiền (50061), xóa sổ cái (50060), sửa trực tiếp số dư ví (50062); thủ tục hoàn tiền từ chối khoản đã xuất hóa đơn (50063).</a:t>
-            </a:r>
-          </a:p>
-        </p:txBody>
-      </p:sp>
-      <p:sp>
-        <p:nvSpPr>
-          <p:cNvPr id="5" name="Rounded Rectangle 4"/>
-          <p:cNvSpPr/>
-          <p:nvPr/>
-        </p:nvSpPr>
-        <p:spPr>
-          <a:xfrm>
-            <a:off x="6278270" y="1280160"/>
-            <a:ext cx="5180990" cy="4937760"/>
-          </a:xfrm>
-          <a:prstGeom prst="roundRect">
-            <a:avLst>
-              <a:gd name="adj" fmla="val 1500"/>
-            </a:avLst>
-          </a:prstGeom>
-          <a:solidFill>
-            <a:srgbClr val="FFFFFF"/>
-          </a:solidFill>
-          <a:ln w="12700">
-            <a:solidFill>
-              <a:srgbClr val="E2E8F0"/>
-            </a:solidFill>
-          </a:ln>
-        </p:spPr>
-        <p:style>
-          <a:lnRef idx="1">
-            <a:schemeClr val="accent1"/>
-          </a:lnRef>
-          <a:fillRef idx="3">
-            <a:schemeClr val="accent1"/>
-          </a:fillRef>
-          <a:effectRef idx="2">
-            <a:schemeClr val="accent1"/>
-          </a:effectRef>
-          <a:fontRef idx="minor">
-            <a:schemeClr val="lt1"/>
-          </a:fontRef>
-        </p:style>
-        <p:txBody>
-          <a:bodyPr rtlCol="0" anchor="ctr"/>
-          <a:lstStyle/>
-          <a:p>
-            <a:pPr algn="ctr"/>
-            <a:endParaRPr/>
-          </a:p>
-        </p:txBody>
-      </p:sp>
-      <p:sp>
-        <p:nvSpPr>
-          <p:cNvPr id="6" name="TextBox 5"/>
-          <p:cNvSpPr txBox="1"/>
-          <p:nvPr/>
-        </p:nvSpPr>
-        <p:spPr>
-          <a:xfrm>
-            <a:off x="6506870" y="1508760"/>
-            <a:ext cx="4723790" cy="4480560"/>
-          </a:xfrm>
-          <a:prstGeom prst="rect">
-            <a:avLst/>
-          </a:prstGeom>
-          <a:noFill/>
-        </p:spPr>
-        <p:txBody>
-          <a:bodyPr wrap="square" lIns="0" tIns="0" rIns="0" bIns="0">
-            <a:spAutoFit/>
-          </a:bodyPr>
-          <a:lstStyle/>
-          <a:p>
-            <a:pPr>
-              <a:spcAft>
-                <a:spcPts val="1000"/>
-              </a:spcAft>
-              <a:defRPr sz="1400" b="1">
-                <a:solidFill>
-                  <a:srgbClr val="0F172A"/>
-                </a:solidFill>
-                <a:latin typeface="Arial"/>
-              </a:defRPr>
-            </a:pPr>
-            <a:r>
-              <a:t>🗄️ CÁC BẢNG DỮ LIỆU &amp; ĐỐI TƯỢNG CSDL LIÊN QUAN</a:t>
-            </a:r>
-          </a:p>
-          <a:p>
-            <a:pPr>
-              <a:spcAft>
-                <a:spcPts val="400"/>
-              </a:spcAft>
-              <a:defRPr sz="1200" b="1">
-                <a:solidFill>
-                  <a:srgbClr val="0F172A"/>
-                </a:solidFill>
-                <a:latin typeface="Arial"/>
-              </a:defRPr>
-            </a:pPr>
-            <a:r>
-              <a:t>• Các bảng dữ liệu bị ảnh hưởng / truy vấn:</a:t>
-            </a:r>
-          </a:p>
-          <a:p>
-            <a:pPr>
-              <a:spcAft>
-                <a:spcPts val="300"/>
-              </a:spcAft>
-              <a:defRPr sz="1150">
-                <a:solidFill>
-                  <a:srgbClr val="0F172A"/>
-                </a:solidFill>
-                <a:latin typeface="Arial"/>
-              </a:defRPr>
-            </a:pPr>
-            <a:r>
-              <a:t>    - GIAO_DICH (Sổ cái kế toán ghi nhận giao dịch)</a:t>
-            </a:r>
-          </a:p>
-          <a:p>
-            <a:pPr>
-              <a:spcAft>
-                <a:spcPts val="300"/>
-              </a:spcAft>
-              <a:defRPr sz="1150">
-                <a:solidFill>
-                  <a:srgbClr val="0F172A"/>
-                </a:solidFill>
-                <a:latin typeface="Arial"/>
-              </a:defRPr>
-            </a:pPr>
-            <a:r>
-              <a:t>    - HOA_DON_VE_THANG (Kiểm tra khoản đã xuất hóa đơn trước khi hoàn tiền)</a:t>
-            </a:r>
-          </a:p>
-          <a:p>
-            <a:pPr>
-              <a:spcAft>
-                <a:spcPts val="300"/>
-              </a:spcAft>
-              <a:defRPr sz="1150">
-                <a:solidFill>
-                  <a:srgbClr val="0F172A"/>
-                </a:solidFill>
-                <a:latin typeface="Arial"/>
-              </a:defRPr>
-            </a:pPr>
-            <a:r>
-              <a:t>    - VI_DIEN_TU (Đối soát số dư ví)</a:t>
-            </a:r>
-          </a:p>
-          <a:p>
-            <a:pPr>
-              <a:spcBef>
-                <a:spcPts val="800"/>
-              </a:spcBef>
-              <a:spcAft>
-                <a:spcPts val="400"/>
-              </a:spcAft>
-              <a:defRPr sz="1200" b="1">
-                <a:solidFill>
-                  <a:srgbClr val="0284C7"/>
-                </a:solidFill>
-                <a:latin typeface="Arial"/>
-              </a:defRPr>
-            </a:pPr>
-            <a:r>
-              <a:t>• Đối tượng T-SQL xử lý cốt lõi:</a:t>
-            </a:r>
-          </a:p>
-          <a:p>
-            <a:pPr>
-              <a:defRPr sz="1150" b="1">
-                <a:solidFill>
-                  <a:srgbClr val="0F172A"/>
-                </a:solidFill>
-                <a:latin typeface="Arial"/>
-              </a:defRPr>
-            </a:pPr>
-            <a:r>
-              <a:t>    Trigger trg_GiaoDich_BatBien + trg_GiaoDich_ChanXoa + Stored Procedure sp_NV_HoanTien (Ghi bút toán đối ứng)</a:t>
             </a:r>
           </a:p>
         </p:txBody>

</xml_diff>